<commit_message>
Finish coin change problem explanation plan
</commit_message>
<xml_diff>
--- a/MyOwnPresentations/Dynamic_Programming_III.pptx
+++ b/MyOwnPresentations/Dynamic_Programming_III.pptx
@@ -17,11 +17,27 @@
     <p:sldId id="262" r:id="rId11"/>
     <p:sldId id="265" r:id="rId12"/>
     <p:sldId id="266" r:id="rId13"/>
-    <p:sldId id="267" r:id="rId14"/>
-    <p:sldId id="268" r:id="rId15"/>
-    <p:sldId id="269" r:id="rId16"/>
-    <p:sldId id="270" r:id="rId17"/>
-    <p:sldId id="271" r:id="rId18"/>
+    <p:sldId id="273" r:id="rId14"/>
+    <p:sldId id="274" r:id="rId15"/>
+    <p:sldId id="275" r:id="rId16"/>
+    <p:sldId id="272" r:id="rId17"/>
+    <p:sldId id="267" r:id="rId18"/>
+    <p:sldId id="268" r:id="rId19"/>
+    <p:sldId id="269" r:id="rId20"/>
+    <p:sldId id="283" r:id="rId21"/>
+    <p:sldId id="284" r:id="rId22"/>
+    <p:sldId id="285" r:id="rId23"/>
+    <p:sldId id="270" r:id="rId24"/>
+    <p:sldId id="276" r:id="rId25"/>
+    <p:sldId id="277" r:id="rId26"/>
+    <p:sldId id="278" r:id="rId27"/>
+    <p:sldId id="279" r:id="rId28"/>
+    <p:sldId id="281" r:id="rId29"/>
+    <p:sldId id="286" r:id="rId30"/>
+    <p:sldId id="287" r:id="rId31"/>
+    <p:sldId id="282" r:id="rId32"/>
+    <p:sldId id="271" r:id="rId33"/>
+    <p:sldId id="288" r:id="rId34"/>
   </p:sldIdLst>
   <p:sldSz cx="12192000" cy="6858000"/>
   <p:notesSz cx="6858000" cy="9144000"/>
@@ -275,7 +291,7 @@
           <a:p>
             <a:fld id="{DC2868A1-B458-41A6-8BAE-A278B7B597FD}" type="datetimeFigureOut">
               <a:rPr lang="en-US" smtClean="0"/>
-              <a:t>8/28/2025</a:t>
+              <a:t>8/29/2025</a:t>
             </a:fld>
             <a:endParaRPr lang="en-US"/>
           </a:p>
@@ -473,7 +489,7 @@
           <a:p>
             <a:fld id="{DC2868A1-B458-41A6-8BAE-A278B7B597FD}" type="datetimeFigureOut">
               <a:rPr lang="en-US" smtClean="0"/>
-              <a:t>8/28/2025</a:t>
+              <a:t>8/29/2025</a:t>
             </a:fld>
             <a:endParaRPr lang="en-US"/>
           </a:p>
@@ -681,7 +697,7 @@
           <a:p>
             <a:fld id="{DC2868A1-B458-41A6-8BAE-A278B7B597FD}" type="datetimeFigureOut">
               <a:rPr lang="en-US" smtClean="0"/>
-              <a:t>8/28/2025</a:t>
+              <a:t>8/29/2025</a:t>
             </a:fld>
             <a:endParaRPr lang="en-US"/>
           </a:p>
@@ -901,7 +917,7 @@
           <a:p>
             <a:fld id="{5C041930-F8FC-4542-827E-E504F4750562}" type="datetimeFigureOut">
               <a:rPr lang="en-US" smtClean="0"/>
-              <a:t>8/28/2025</a:t>
+              <a:t>8/29/2025</a:t>
             </a:fld>
             <a:endParaRPr lang="en-US"/>
           </a:p>
@@ -1099,7 +1115,7 @@
           <a:p>
             <a:fld id="{5C041930-F8FC-4542-827E-E504F4750562}" type="datetimeFigureOut">
               <a:rPr lang="en-US" smtClean="0"/>
-              <a:t>8/28/2025</a:t>
+              <a:t>8/29/2025</a:t>
             </a:fld>
             <a:endParaRPr lang="en-US"/>
           </a:p>
@@ -1374,7 +1390,7 @@
           <a:p>
             <a:fld id="{5C041930-F8FC-4542-827E-E504F4750562}" type="datetimeFigureOut">
               <a:rPr lang="en-US" smtClean="0"/>
-              <a:t>8/28/2025</a:t>
+              <a:t>8/29/2025</a:t>
             </a:fld>
             <a:endParaRPr lang="en-US"/>
           </a:p>
@@ -1639,7 +1655,7 @@
           <a:p>
             <a:fld id="{5C041930-F8FC-4542-827E-E504F4750562}" type="datetimeFigureOut">
               <a:rPr lang="en-US" smtClean="0"/>
-              <a:t>8/28/2025</a:t>
+              <a:t>8/29/2025</a:t>
             </a:fld>
             <a:endParaRPr lang="en-US"/>
           </a:p>
@@ -2051,7 +2067,7 @@
           <a:p>
             <a:fld id="{5C041930-F8FC-4542-827E-E504F4750562}" type="datetimeFigureOut">
               <a:rPr lang="en-US" smtClean="0"/>
-              <a:t>8/28/2025</a:t>
+              <a:t>8/29/2025</a:t>
             </a:fld>
             <a:endParaRPr lang="en-US"/>
           </a:p>
@@ -2192,7 +2208,7 @@
           <a:p>
             <a:fld id="{5C041930-F8FC-4542-827E-E504F4750562}" type="datetimeFigureOut">
               <a:rPr lang="en-US" smtClean="0"/>
-              <a:t>8/28/2025</a:t>
+              <a:t>8/29/2025</a:t>
             </a:fld>
             <a:endParaRPr lang="en-US"/>
           </a:p>
@@ -2305,7 +2321,7 @@
           <a:p>
             <a:fld id="{5C041930-F8FC-4542-827E-E504F4750562}" type="datetimeFigureOut">
               <a:rPr lang="en-US" smtClean="0"/>
-              <a:t>8/28/2025</a:t>
+              <a:t>8/29/2025</a:t>
             </a:fld>
             <a:endParaRPr lang="en-US"/>
           </a:p>
@@ -2616,7 +2632,7 @@
           <a:p>
             <a:fld id="{5C041930-F8FC-4542-827E-E504F4750562}" type="datetimeFigureOut">
               <a:rPr lang="en-US" smtClean="0"/>
-              <a:t>8/28/2025</a:t>
+              <a:t>8/29/2025</a:t>
             </a:fld>
             <a:endParaRPr lang="en-US"/>
           </a:p>
@@ -2814,7 +2830,7 @@
           <a:p>
             <a:fld id="{DC2868A1-B458-41A6-8BAE-A278B7B597FD}" type="datetimeFigureOut">
               <a:rPr lang="en-US" smtClean="0"/>
-              <a:t>8/28/2025</a:t>
+              <a:t>8/29/2025</a:t>
             </a:fld>
             <a:endParaRPr lang="en-US"/>
           </a:p>
@@ -3102,7 +3118,7 @@
           <a:p>
             <a:fld id="{5C041930-F8FC-4542-827E-E504F4750562}" type="datetimeFigureOut">
               <a:rPr lang="en-US" smtClean="0"/>
-              <a:t>8/28/2025</a:t>
+              <a:t>8/29/2025</a:t>
             </a:fld>
             <a:endParaRPr lang="en-US"/>
           </a:p>
@@ -3300,7 +3316,7 @@
           <a:p>
             <a:fld id="{5C041930-F8FC-4542-827E-E504F4750562}" type="datetimeFigureOut">
               <a:rPr lang="en-US" smtClean="0"/>
-              <a:t>8/28/2025</a:t>
+              <a:t>8/29/2025</a:t>
             </a:fld>
             <a:endParaRPr lang="en-US"/>
           </a:p>
@@ -3508,7 +3524,7 @@
           <a:p>
             <a:fld id="{5C041930-F8FC-4542-827E-E504F4750562}" type="datetimeFigureOut">
               <a:rPr lang="en-US" smtClean="0"/>
-              <a:t>8/28/2025</a:t>
+              <a:t>8/29/2025</a:t>
             </a:fld>
             <a:endParaRPr lang="en-US"/>
           </a:p>
@@ -3783,7 +3799,7 @@
           <a:p>
             <a:fld id="{DC2868A1-B458-41A6-8BAE-A278B7B597FD}" type="datetimeFigureOut">
               <a:rPr lang="en-US" smtClean="0"/>
-              <a:t>8/28/2025</a:t>
+              <a:t>8/29/2025</a:t>
             </a:fld>
             <a:endParaRPr lang="en-US"/>
           </a:p>
@@ -4048,7 +4064,7 @@
           <a:p>
             <a:fld id="{DC2868A1-B458-41A6-8BAE-A278B7B597FD}" type="datetimeFigureOut">
               <a:rPr lang="en-US" smtClean="0"/>
-              <a:t>8/28/2025</a:t>
+              <a:t>8/29/2025</a:t>
             </a:fld>
             <a:endParaRPr lang="en-US"/>
           </a:p>
@@ -4460,7 +4476,7 @@
           <a:p>
             <a:fld id="{DC2868A1-B458-41A6-8BAE-A278B7B597FD}" type="datetimeFigureOut">
               <a:rPr lang="en-US" smtClean="0"/>
-              <a:t>8/28/2025</a:t>
+              <a:t>8/29/2025</a:t>
             </a:fld>
             <a:endParaRPr lang="en-US"/>
           </a:p>
@@ -4601,7 +4617,7 @@
           <a:p>
             <a:fld id="{DC2868A1-B458-41A6-8BAE-A278B7B597FD}" type="datetimeFigureOut">
               <a:rPr lang="en-US" smtClean="0"/>
-              <a:t>8/28/2025</a:t>
+              <a:t>8/29/2025</a:t>
             </a:fld>
             <a:endParaRPr lang="en-US"/>
           </a:p>
@@ -4714,7 +4730,7 @@
           <a:p>
             <a:fld id="{DC2868A1-B458-41A6-8BAE-A278B7B597FD}" type="datetimeFigureOut">
               <a:rPr lang="en-US" smtClean="0"/>
-              <a:t>8/28/2025</a:t>
+              <a:t>8/29/2025</a:t>
             </a:fld>
             <a:endParaRPr lang="en-US"/>
           </a:p>
@@ -5025,7 +5041,7 @@
           <a:p>
             <a:fld id="{DC2868A1-B458-41A6-8BAE-A278B7B597FD}" type="datetimeFigureOut">
               <a:rPr lang="en-US" smtClean="0"/>
-              <a:t>8/28/2025</a:t>
+              <a:t>8/29/2025</a:t>
             </a:fld>
             <a:endParaRPr lang="en-US"/>
           </a:p>
@@ -5313,7 +5329,7 @@
           <a:p>
             <a:fld id="{DC2868A1-B458-41A6-8BAE-A278B7B597FD}" type="datetimeFigureOut">
               <a:rPr lang="en-US" smtClean="0"/>
-              <a:t>8/28/2025</a:t>
+              <a:t>8/29/2025</a:t>
             </a:fld>
             <a:endParaRPr lang="en-US"/>
           </a:p>
@@ -5554,7 +5570,7 @@
           <a:p>
             <a:fld id="{DC2868A1-B458-41A6-8BAE-A278B7B597FD}" type="datetimeFigureOut">
               <a:rPr lang="en-US" smtClean="0"/>
-              <a:t>8/28/2025</a:t>
+              <a:t>8/29/2025</a:t>
             </a:fld>
             <a:endParaRPr lang="en-US"/>
           </a:p>
@@ -6122,7 +6138,7 @@
           <a:p>
             <a:fld id="{5C041930-F8FC-4542-827E-E504F4750562}" type="datetimeFigureOut">
               <a:rPr lang="en-US" smtClean="0"/>
-              <a:t>8/28/2025</a:t>
+              <a:t>8/29/2025</a:t>
             </a:fld>
             <a:endParaRPr lang="en-US"/>
           </a:p>
@@ -7610,6 +7626,58 @@
           </a:xfrm>
         </p:spPr>
       </p:pic>
+      <p:sp>
+        <p:nvSpPr>
+          <p:cNvPr id="2" name="Rectangle 1">
+            <a:extLst>
+              <a:ext uri="{FF2B5EF4-FFF2-40B4-BE49-F238E27FC236}">
+                <a16:creationId xmlns:a16="http://schemas.microsoft.com/office/drawing/2014/main" id="{41BBCA49-B929-0326-E8B8-B3D12CB882AA}"/>
+              </a:ext>
+            </a:extLst>
+          </p:cNvPr>
+          <p:cNvSpPr/>
+          <p:nvPr/>
+        </p:nvSpPr>
+        <p:spPr>
+          <a:xfrm>
+            <a:off x="1284514" y="1034143"/>
+            <a:ext cx="9840686" cy="5366657"/>
+          </a:xfrm>
+          <a:prstGeom prst="rect">
+            <a:avLst/>
+          </a:prstGeom>
+          <a:solidFill>
+            <a:schemeClr val="bg1"/>
+          </a:solidFill>
+          <a:ln>
+            <a:noFill/>
+          </a:ln>
+        </p:spPr>
+        <p:style>
+          <a:lnRef idx="2">
+            <a:schemeClr val="accent1">
+              <a:shade val="15000"/>
+            </a:schemeClr>
+          </a:lnRef>
+          <a:fillRef idx="1">
+            <a:schemeClr val="accent1"/>
+          </a:fillRef>
+          <a:effectRef idx="0">
+            <a:schemeClr val="accent1"/>
+          </a:effectRef>
+          <a:fontRef idx="minor">
+            <a:schemeClr val="lt1"/>
+          </a:fontRef>
+        </p:style>
+        <p:txBody>
+          <a:bodyPr rtlCol="0" anchor="ctr"/>
+          <a:lstStyle/>
+          <a:p>
+            <a:pPr algn="ctr"/>
+            <a:endParaRPr lang="en-US"/>
+          </a:p>
+        </p:txBody>
+      </p:sp>
     </p:spTree>
     <p:extLst>
       <p:ext uri="{BB962C8B-B14F-4D97-AF65-F5344CB8AC3E}">
@@ -7624,6 +7692,442 @@
 </file>
 
 <file path=ppt/slides/slide12.xml><?xml version="1.0" encoding="utf-8"?>
+<p:sld xmlns:a="http://schemas.openxmlformats.org/drawingml/2006/main" xmlns:r="http://schemas.openxmlformats.org/officeDocument/2006/relationships" xmlns:p="http://schemas.openxmlformats.org/presentationml/2006/main">
+  <p:cSld>
+    <p:spTree>
+      <p:nvGrpSpPr>
+        <p:cNvPr id="1" name="">
+          <a:extLst>
+            <a:ext uri="{FF2B5EF4-FFF2-40B4-BE49-F238E27FC236}">
+              <a16:creationId xmlns:a16="http://schemas.microsoft.com/office/drawing/2014/main" id="{00056D6D-5FBB-8D96-A574-FC67F7E2399F}"/>
+            </a:ext>
+          </a:extLst>
+        </p:cNvPr>
+        <p:cNvGrpSpPr/>
+        <p:nvPr/>
+      </p:nvGrpSpPr>
+      <p:grpSpPr>
+        <a:xfrm>
+          <a:off x="0" y="0"/>
+          <a:ext cx="0" cy="0"/>
+          <a:chOff x="0" y="0"/>
+          <a:chExt cx="0" cy="0"/>
+        </a:xfrm>
+      </p:grpSpPr>
+      <p:pic>
+        <p:nvPicPr>
+          <p:cNvPr id="5" name="Content Placeholder 4">
+            <a:extLst>
+              <a:ext uri="{FF2B5EF4-FFF2-40B4-BE49-F238E27FC236}">
+                <a16:creationId xmlns:a16="http://schemas.microsoft.com/office/drawing/2014/main" id="{11AB0FA8-6776-E577-C118-0430D91FA704}"/>
+              </a:ext>
+            </a:extLst>
+          </p:cNvPr>
+          <p:cNvPicPr>
+            <a:picLocks noGrp="1" noChangeAspect="1"/>
+          </p:cNvPicPr>
+          <p:nvPr>
+            <p:ph idx="1"/>
+          </p:nvPr>
+        </p:nvPicPr>
+        <p:blipFill>
+          <a:blip r:embed="rId2">
+            <a:extLst>
+              <a:ext uri="{28A0092B-C50C-407E-A947-70E740481C1C}">
+                <a14:useLocalDpi xmlns:a14="http://schemas.microsoft.com/office/drawing/2010/main" val="0"/>
+              </a:ext>
+            </a:extLst>
+          </a:blip>
+          <a:srcRect/>
+          <a:stretch/>
+        </p:blipFill>
+        <p:spPr>
+          <a:xfrm>
+            <a:off x="1675848" y="616038"/>
+            <a:ext cx="8840303" cy="5625923"/>
+          </a:xfrm>
+        </p:spPr>
+      </p:pic>
+      <p:sp>
+        <p:nvSpPr>
+          <p:cNvPr id="2" name="Rectangle 1">
+            <a:extLst>
+              <a:ext uri="{FF2B5EF4-FFF2-40B4-BE49-F238E27FC236}">
+                <a16:creationId xmlns:a16="http://schemas.microsoft.com/office/drawing/2014/main" id="{22F74F9F-B7CF-C3D9-4434-D69922A41FCB}"/>
+              </a:ext>
+            </a:extLst>
+          </p:cNvPr>
+          <p:cNvSpPr/>
+          <p:nvPr/>
+        </p:nvSpPr>
+        <p:spPr>
+          <a:xfrm>
+            <a:off x="1317171" y="2427514"/>
+            <a:ext cx="9840686" cy="3973286"/>
+          </a:xfrm>
+          <a:prstGeom prst="rect">
+            <a:avLst/>
+          </a:prstGeom>
+          <a:solidFill>
+            <a:schemeClr val="bg1"/>
+          </a:solidFill>
+          <a:ln>
+            <a:noFill/>
+          </a:ln>
+        </p:spPr>
+        <p:style>
+          <a:lnRef idx="2">
+            <a:schemeClr val="accent1">
+              <a:shade val="15000"/>
+            </a:schemeClr>
+          </a:lnRef>
+          <a:fillRef idx="1">
+            <a:schemeClr val="accent1"/>
+          </a:fillRef>
+          <a:effectRef idx="0">
+            <a:schemeClr val="accent1"/>
+          </a:effectRef>
+          <a:fontRef idx="minor">
+            <a:schemeClr val="lt1"/>
+          </a:fontRef>
+        </p:style>
+        <p:txBody>
+          <a:bodyPr rtlCol="0" anchor="ctr"/>
+          <a:lstStyle/>
+          <a:p>
+            <a:pPr algn="ctr"/>
+            <a:endParaRPr lang="en-US"/>
+          </a:p>
+        </p:txBody>
+      </p:sp>
+    </p:spTree>
+    <p:extLst>
+      <p:ext uri="{BB962C8B-B14F-4D97-AF65-F5344CB8AC3E}">
+        <p14:creationId xmlns:p14="http://schemas.microsoft.com/office/powerpoint/2010/main" val="1699971104"/>
+      </p:ext>
+    </p:extLst>
+  </p:cSld>
+  <p:clrMapOvr>
+    <a:masterClrMapping/>
+  </p:clrMapOvr>
+</p:sld>
+</file>
+
+<file path=ppt/slides/slide13.xml><?xml version="1.0" encoding="utf-8"?>
+<p:sld xmlns:a="http://schemas.openxmlformats.org/drawingml/2006/main" xmlns:r="http://schemas.openxmlformats.org/officeDocument/2006/relationships" xmlns:p="http://schemas.openxmlformats.org/presentationml/2006/main">
+  <p:cSld>
+    <p:spTree>
+      <p:nvGrpSpPr>
+        <p:cNvPr id="1" name="">
+          <a:extLst>
+            <a:ext uri="{FF2B5EF4-FFF2-40B4-BE49-F238E27FC236}">
+              <a16:creationId xmlns:a16="http://schemas.microsoft.com/office/drawing/2014/main" id="{09CCE8B5-4FEC-65EF-9A37-6D06F759AA4C}"/>
+            </a:ext>
+          </a:extLst>
+        </p:cNvPr>
+        <p:cNvGrpSpPr/>
+        <p:nvPr/>
+      </p:nvGrpSpPr>
+      <p:grpSpPr>
+        <a:xfrm>
+          <a:off x="0" y="0"/>
+          <a:ext cx="0" cy="0"/>
+          <a:chOff x="0" y="0"/>
+          <a:chExt cx="0" cy="0"/>
+        </a:xfrm>
+      </p:grpSpPr>
+      <p:pic>
+        <p:nvPicPr>
+          <p:cNvPr id="5" name="Content Placeholder 4">
+            <a:extLst>
+              <a:ext uri="{FF2B5EF4-FFF2-40B4-BE49-F238E27FC236}">
+                <a16:creationId xmlns:a16="http://schemas.microsoft.com/office/drawing/2014/main" id="{381A05F3-B85C-9C3B-F4B7-3FC86786F527}"/>
+              </a:ext>
+            </a:extLst>
+          </p:cNvPr>
+          <p:cNvPicPr>
+            <a:picLocks noGrp="1" noChangeAspect="1"/>
+          </p:cNvPicPr>
+          <p:nvPr>
+            <p:ph idx="1"/>
+          </p:nvPr>
+        </p:nvPicPr>
+        <p:blipFill>
+          <a:blip r:embed="rId2">
+            <a:extLst>
+              <a:ext uri="{28A0092B-C50C-407E-A947-70E740481C1C}">
+                <a14:useLocalDpi xmlns:a14="http://schemas.microsoft.com/office/drawing/2010/main" val="0"/>
+              </a:ext>
+            </a:extLst>
+          </a:blip>
+          <a:srcRect/>
+          <a:stretch/>
+        </p:blipFill>
+        <p:spPr>
+          <a:xfrm>
+            <a:off x="1675848" y="616038"/>
+            <a:ext cx="8840303" cy="5625923"/>
+          </a:xfrm>
+        </p:spPr>
+      </p:pic>
+      <p:sp>
+        <p:nvSpPr>
+          <p:cNvPr id="2" name="Rectangle 1">
+            <a:extLst>
+              <a:ext uri="{FF2B5EF4-FFF2-40B4-BE49-F238E27FC236}">
+                <a16:creationId xmlns:a16="http://schemas.microsoft.com/office/drawing/2014/main" id="{3419F776-D2E5-FCD9-BC15-0BB0E4F6A0B0}"/>
+              </a:ext>
+            </a:extLst>
+          </p:cNvPr>
+          <p:cNvSpPr/>
+          <p:nvPr/>
+        </p:nvSpPr>
+        <p:spPr>
+          <a:xfrm>
+            <a:off x="1317171" y="4180114"/>
+            <a:ext cx="9840686" cy="2220686"/>
+          </a:xfrm>
+          <a:prstGeom prst="rect">
+            <a:avLst/>
+          </a:prstGeom>
+          <a:solidFill>
+            <a:schemeClr val="bg1"/>
+          </a:solidFill>
+          <a:ln>
+            <a:noFill/>
+          </a:ln>
+        </p:spPr>
+        <p:style>
+          <a:lnRef idx="2">
+            <a:schemeClr val="accent1">
+              <a:shade val="15000"/>
+            </a:schemeClr>
+          </a:lnRef>
+          <a:fillRef idx="1">
+            <a:schemeClr val="accent1"/>
+          </a:fillRef>
+          <a:effectRef idx="0">
+            <a:schemeClr val="accent1"/>
+          </a:effectRef>
+          <a:fontRef idx="minor">
+            <a:schemeClr val="lt1"/>
+          </a:fontRef>
+        </p:style>
+        <p:txBody>
+          <a:bodyPr rtlCol="0" anchor="ctr"/>
+          <a:lstStyle/>
+          <a:p>
+            <a:pPr algn="ctr"/>
+            <a:endParaRPr lang="en-US"/>
+          </a:p>
+        </p:txBody>
+      </p:sp>
+    </p:spTree>
+    <p:extLst>
+      <p:ext uri="{BB962C8B-B14F-4D97-AF65-F5344CB8AC3E}">
+        <p14:creationId xmlns:p14="http://schemas.microsoft.com/office/powerpoint/2010/main" val="2286083213"/>
+      </p:ext>
+    </p:extLst>
+  </p:cSld>
+  <p:clrMapOvr>
+    <a:masterClrMapping/>
+  </p:clrMapOvr>
+</p:sld>
+</file>
+
+<file path=ppt/slides/slide14.xml><?xml version="1.0" encoding="utf-8"?>
+<p:sld xmlns:a="http://schemas.openxmlformats.org/drawingml/2006/main" xmlns:r="http://schemas.openxmlformats.org/officeDocument/2006/relationships" xmlns:p="http://schemas.openxmlformats.org/presentationml/2006/main">
+  <p:cSld>
+    <p:spTree>
+      <p:nvGrpSpPr>
+        <p:cNvPr id="1" name="">
+          <a:extLst>
+            <a:ext uri="{FF2B5EF4-FFF2-40B4-BE49-F238E27FC236}">
+              <a16:creationId xmlns:a16="http://schemas.microsoft.com/office/drawing/2014/main" id="{CB243B88-0D9A-A62C-D31B-59791276F6E5}"/>
+            </a:ext>
+          </a:extLst>
+        </p:cNvPr>
+        <p:cNvGrpSpPr/>
+        <p:nvPr/>
+      </p:nvGrpSpPr>
+      <p:grpSpPr>
+        <a:xfrm>
+          <a:off x="0" y="0"/>
+          <a:ext cx="0" cy="0"/>
+          <a:chOff x="0" y="0"/>
+          <a:chExt cx="0" cy="0"/>
+        </a:xfrm>
+      </p:grpSpPr>
+      <p:pic>
+        <p:nvPicPr>
+          <p:cNvPr id="5" name="Content Placeholder 4">
+            <a:extLst>
+              <a:ext uri="{FF2B5EF4-FFF2-40B4-BE49-F238E27FC236}">
+                <a16:creationId xmlns:a16="http://schemas.microsoft.com/office/drawing/2014/main" id="{03D78DD6-9899-9A13-A291-004915FF0DDF}"/>
+              </a:ext>
+            </a:extLst>
+          </p:cNvPr>
+          <p:cNvPicPr>
+            <a:picLocks noGrp="1" noChangeAspect="1"/>
+          </p:cNvPicPr>
+          <p:nvPr>
+            <p:ph idx="1"/>
+          </p:nvPr>
+        </p:nvPicPr>
+        <p:blipFill>
+          <a:blip r:embed="rId2">
+            <a:extLst>
+              <a:ext uri="{28A0092B-C50C-407E-A947-70E740481C1C}">
+                <a14:useLocalDpi xmlns:a14="http://schemas.microsoft.com/office/drawing/2010/main" val="0"/>
+              </a:ext>
+            </a:extLst>
+          </a:blip>
+          <a:srcRect/>
+          <a:stretch/>
+        </p:blipFill>
+        <p:spPr>
+          <a:xfrm>
+            <a:off x="1675848" y="616038"/>
+            <a:ext cx="8840303" cy="5625923"/>
+          </a:xfrm>
+        </p:spPr>
+      </p:pic>
+      <p:sp>
+        <p:nvSpPr>
+          <p:cNvPr id="2" name="Rectangle 1">
+            <a:extLst>
+              <a:ext uri="{FF2B5EF4-FFF2-40B4-BE49-F238E27FC236}">
+                <a16:creationId xmlns:a16="http://schemas.microsoft.com/office/drawing/2014/main" id="{34A7D16E-C7F0-A00A-69C0-A57C4A5C5ED5}"/>
+              </a:ext>
+            </a:extLst>
+          </p:cNvPr>
+          <p:cNvSpPr/>
+          <p:nvPr/>
+        </p:nvSpPr>
+        <p:spPr>
+          <a:xfrm>
+            <a:off x="1317171" y="5018314"/>
+            <a:ext cx="9840686" cy="1382486"/>
+          </a:xfrm>
+          <a:prstGeom prst="rect">
+            <a:avLst/>
+          </a:prstGeom>
+          <a:solidFill>
+            <a:schemeClr val="bg1"/>
+          </a:solidFill>
+          <a:ln>
+            <a:noFill/>
+          </a:ln>
+        </p:spPr>
+        <p:style>
+          <a:lnRef idx="2">
+            <a:schemeClr val="accent1">
+              <a:shade val="15000"/>
+            </a:schemeClr>
+          </a:lnRef>
+          <a:fillRef idx="1">
+            <a:schemeClr val="accent1"/>
+          </a:fillRef>
+          <a:effectRef idx="0">
+            <a:schemeClr val="accent1"/>
+          </a:effectRef>
+          <a:fontRef idx="minor">
+            <a:schemeClr val="lt1"/>
+          </a:fontRef>
+        </p:style>
+        <p:txBody>
+          <a:bodyPr rtlCol="0" anchor="ctr"/>
+          <a:lstStyle/>
+          <a:p>
+            <a:pPr algn="ctr"/>
+            <a:endParaRPr lang="en-US"/>
+          </a:p>
+        </p:txBody>
+      </p:sp>
+    </p:spTree>
+    <p:extLst>
+      <p:ext uri="{BB962C8B-B14F-4D97-AF65-F5344CB8AC3E}">
+        <p14:creationId xmlns:p14="http://schemas.microsoft.com/office/powerpoint/2010/main" val="3319597886"/>
+      </p:ext>
+    </p:extLst>
+  </p:cSld>
+  <p:clrMapOvr>
+    <a:masterClrMapping/>
+  </p:clrMapOvr>
+</p:sld>
+</file>
+
+<file path=ppt/slides/slide15.xml><?xml version="1.0" encoding="utf-8"?>
+<p:sld xmlns:a="http://schemas.openxmlformats.org/drawingml/2006/main" xmlns:r="http://schemas.openxmlformats.org/officeDocument/2006/relationships" xmlns:p="http://schemas.openxmlformats.org/presentationml/2006/main">
+  <p:cSld>
+    <p:spTree>
+      <p:nvGrpSpPr>
+        <p:cNvPr id="1" name="">
+          <a:extLst>
+            <a:ext uri="{FF2B5EF4-FFF2-40B4-BE49-F238E27FC236}">
+              <a16:creationId xmlns:a16="http://schemas.microsoft.com/office/drawing/2014/main" id="{48BB52E3-A138-3B31-782D-5631F9FB144A}"/>
+            </a:ext>
+          </a:extLst>
+        </p:cNvPr>
+        <p:cNvGrpSpPr/>
+        <p:nvPr/>
+      </p:nvGrpSpPr>
+      <p:grpSpPr>
+        <a:xfrm>
+          <a:off x="0" y="0"/>
+          <a:ext cx="0" cy="0"/>
+          <a:chOff x="0" y="0"/>
+          <a:chExt cx="0" cy="0"/>
+        </a:xfrm>
+      </p:grpSpPr>
+      <p:pic>
+        <p:nvPicPr>
+          <p:cNvPr id="5" name="Content Placeholder 4">
+            <a:extLst>
+              <a:ext uri="{FF2B5EF4-FFF2-40B4-BE49-F238E27FC236}">
+                <a16:creationId xmlns:a16="http://schemas.microsoft.com/office/drawing/2014/main" id="{CE761A93-A63F-7840-44BC-C446184D3046}"/>
+              </a:ext>
+            </a:extLst>
+          </p:cNvPr>
+          <p:cNvPicPr>
+            <a:picLocks noGrp="1" noChangeAspect="1"/>
+          </p:cNvPicPr>
+          <p:nvPr>
+            <p:ph idx="1"/>
+          </p:nvPr>
+        </p:nvPicPr>
+        <p:blipFill>
+          <a:blip r:embed="rId2">
+            <a:extLst>
+              <a:ext uri="{28A0092B-C50C-407E-A947-70E740481C1C}">
+                <a14:useLocalDpi xmlns:a14="http://schemas.microsoft.com/office/drawing/2010/main" val="0"/>
+              </a:ext>
+            </a:extLst>
+          </a:blip>
+          <a:srcRect/>
+          <a:stretch/>
+        </p:blipFill>
+        <p:spPr>
+          <a:xfrm>
+            <a:off x="1675848" y="616038"/>
+            <a:ext cx="8840303" cy="5625923"/>
+          </a:xfrm>
+        </p:spPr>
+      </p:pic>
+    </p:spTree>
+    <p:extLst>
+      <p:ext uri="{BB962C8B-B14F-4D97-AF65-F5344CB8AC3E}">
+        <p14:creationId xmlns:p14="http://schemas.microsoft.com/office/powerpoint/2010/main" val="3537175830"/>
+      </p:ext>
+    </p:extLst>
+  </p:cSld>
+  <p:clrMapOvr>
+    <a:masterClrMapping/>
+  </p:clrMapOvr>
+</p:sld>
+</file>
+
+<file path=ppt/slides/slide16.xml><?xml version="1.0" encoding="utf-8"?>
 <p:sld xmlns:a="http://schemas.openxmlformats.org/drawingml/2006/main" xmlns:r="http://schemas.openxmlformats.org/officeDocument/2006/relationships" xmlns:p="http://schemas.openxmlformats.org/presentationml/2006/main">
   <p:cSld>
     <p:spTree>
@@ -7669,7 +8173,7 @@
         </p:blipFill>
         <p:spPr>
           <a:xfrm>
-            <a:off x="3310691" y="61015"/>
+            <a:off x="3539291" y="61015"/>
             <a:ext cx="8652709" cy="6735970"/>
           </a:xfrm>
         </p:spPr>
@@ -7731,8 +8235,8 @@
         </p:blipFill>
         <p:spPr>
           <a:xfrm>
-            <a:off x="228600" y="1669814"/>
-            <a:ext cx="2978386" cy="2978386"/>
+            <a:off x="109574" y="1523999"/>
+            <a:ext cx="3320143" cy="3320143"/>
           </a:xfrm>
           <a:prstGeom prst="rect">
             <a:avLst/>
@@ -7752,7 +8256,7 @@
 </p:sld>
 </file>
 
-<file path=ppt/slides/slide13.xml><?xml version="1.0" encoding="utf-8"?>
+<file path=ppt/slides/slide17.xml><?xml version="1.0" encoding="utf-8"?>
 <p:sld xmlns:a="http://schemas.openxmlformats.org/drawingml/2006/main" xmlns:r="http://schemas.openxmlformats.org/officeDocument/2006/relationships" xmlns:p="http://schemas.openxmlformats.org/presentationml/2006/main">
   <p:cSld>
     <p:bg>
@@ -8166,7 +8670,7 @@
 </p:sld>
 </file>
 
-<file path=ppt/slides/slide14.xml><?xml version="1.0" encoding="utf-8"?>
+<file path=ppt/slides/slide18.xml><?xml version="1.0" encoding="utf-8"?>
 <p:sld xmlns:a="http://schemas.openxmlformats.org/drawingml/2006/main" xmlns:r="http://schemas.openxmlformats.org/officeDocument/2006/relationships" xmlns:p="http://schemas.openxmlformats.org/presentationml/2006/main">
   <p:cSld>
     <p:bg>
@@ -8394,9 +8898,20 @@
 </p:sld>
 </file>
 
-<file path=ppt/slides/slide15.xml><?xml version="1.0" encoding="utf-8"?>
+<file path=ppt/slides/slide19.xml><?xml version="1.0" encoding="utf-8"?>
 <p:sld xmlns:a="http://schemas.openxmlformats.org/drawingml/2006/main" xmlns:r="http://schemas.openxmlformats.org/officeDocument/2006/relationships" xmlns:p="http://schemas.openxmlformats.org/presentationml/2006/main">
   <p:cSld>
+    <p:bg>
+      <p:bgPr>
+        <a:solidFill>
+          <a:schemeClr val="bg1">
+            <a:tint val="95000"/>
+            <a:satMod val="170000"/>
+          </a:schemeClr>
+        </a:solidFill>
+        <a:effectLst/>
+      </p:bgPr>
+    </p:bg>
     <p:spTree>
       <p:nvGrpSpPr>
         <p:cNvPr id="1" name=""/>
@@ -8413,170 +8928,386 @@
       </p:grpSpPr>
       <p:sp>
         <p:nvSpPr>
-          <p:cNvPr id="4" name="TextBox 3">
-            <a:extLst>
-              <a:ext uri="{FF2B5EF4-FFF2-40B4-BE49-F238E27FC236}">
-                <a16:creationId xmlns:a16="http://schemas.microsoft.com/office/drawing/2014/main" id="{F9A826B7-5B7F-F2C1-16F7-53B040506C50}"/>
-              </a:ext>
-            </a:extLst>
-          </p:cNvPr>
-          <p:cNvSpPr txBox="1"/>
-          <p:nvPr/>
+          <p:cNvPr id="7" name="Freeform: Shape 6">
+            <a:extLst>
+              <a:ext uri="{FF2B5EF4-FFF2-40B4-BE49-F238E27FC236}">
+                <a16:creationId xmlns:a16="http://schemas.microsoft.com/office/drawing/2014/main" id="{66B332A4-D438-4773-A77F-5ED49A448D9D}"/>
+              </a:ext>
+              <a:ext uri="{C183D7F6-B498-43B3-948B-1728B52AA6E4}">
+                <adec:decorative xmlns:adec="http://schemas.microsoft.com/office/drawing/2017/decorative" val="1"/>
+              </a:ext>
+            </a:extLst>
+          </p:cNvPr>
+          <p:cNvSpPr>
+            <a:spLocks noGrp="1" noRot="1" noChangeAspect="1" noMove="1" noResize="1" noEditPoints="1" noAdjustHandles="1" noChangeArrowheads="1" noChangeShapeType="1" noTextEdit="1"/>
+          </p:cNvSpPr>
+          <p:nvPr>
+            <p:extLst>
+              <p:ext uri="{386F3935-93C4-4BCD-93E2-E3B085C9AB24}">
+                <p16:designElem xmlns:p16="http://schemas.microsoft.com/office/powerpoint/2015/main" val="1"/>
+              </p:ext>
+            </p:extLst>
+          </p:nvPr>
         </p:nvSpPr>
         <p:spPr>
           <a:xfrm>
-            <a:off x="1175657" y="435429"/>
-            <a:ext cx="5233292" cy="646331"/>
+            <a:off x="1953768" y="0"/>
+            <a:ext cx="8284464" cy="6858000"/>
           </a:xfrm>
-          <a:prstGeom prst="rect">
+          <a:custGeom>
             <a:avLst/>
-          </a:prstGeom>
-          <a:noFill/>
+            <a:gdLst>
+              <a:gd name="connsiteX0" fmla="*/ 1818109 w 8284464"/>
+              <a:gd name="connsiteY0" fmla="*/ 0 h 6858000"/>
+              <a:gd name="connsiteX1" fmla="*/ 6466355 w 8284464"/>
+              <a:gd name="connsiteY1" fmla="*/ 0 h 6858000"/>
+              <a:gd name="connsiteX2" fmla="*/ 6620596 w 8284464"/>
+              <a:gd name="connsiteY2" fmla="*/ 109683 h 6858000"/>
+              <a:gd name="connsiteX3" fmla="*/ 8284464 w 8284464"/>
+              <a:gd name="connsiteY3" fmla="*/ 3429000 h 6858000"/>
+              <a:gd name="connsiteX4" fmla="*/ 6620596 w 8284464"/>
+              <a:gd name="connsiteY4" fmla="*/ 6748318 h 6858000"/>
+              <a:gd name="connsiteX5" fmla="*/ 6466355 w 8284464"/>
+              <a:gd name="connsiteY5" fmla="*/ 6858000 h 6858000"/>
+              <a:gd name="connsiteX6" fmla="*/ 1818109 w 8284464"/>
+              <a:gd name="connsiteY6" fmla="*/ 6858000 h 6858000"/>
+              <a:gd name="connsiteX7" fmla="*/ 1663869 w 8284464"/>
+              <a:gd name="connsiteY7" fmla="*/ 6748318 h 6858000"/>
+              <a:gd name="connsiteX8" fmla="*/ 0 w 8284464"/>
+              <a:gd name="connsiteY8" fmla="*/ 3429000 h 6858000"/>
+              <a:gd name="connsiteX9" fmla="*/ 1663869 w 8284464"/>
+              <a:gd name="connsiteY9" fmla="*/ 109683 h 6858000"/>
+            </a:gdLst>
+            <a:ahLst/>
+            <a:cxnLst>
+              <a:cxn ang="0">
+                <a:pos x="connsiteX0" y="connsiteY0"/>
+              </a:cxn>
+              <a:cxn ang="0">
+                <a:pos x="connsiteX1" y="connsiteY1"/>
+              </a:cxn>
+              <a:cxn ang="0">
+                <a:pos x="connsiteX2" y="connsiteY2"/>
+              </a:cxn>
+              <a:cxn ang="0">
+                <a:pos x="connsiteX3" y="connsiteY3"/>
+              </a:cxn>
+              <a:cxn ang="0">
+                <a:pos x="connsiteX4" y="connsiteY4"/>
+              </a:cxn>
+              <a:cxn ang="0">
+                <a:pos x="connsiteX5" y="connsiteY5"/>
+              </a:cxn>
+              <a:cxn ang="0">
+                <a:pos x="connsiteX6" y="connsiteY6"/>
+              </a:cxn>
+              <a:cxn ang="0">
+                <a:pos x="connsiteX7" y="connsiteY7"/>
+              </a:cxn>
+              <a:cxn ang="0">
+                <a:pos x="connsiteX8" y="connsiteY8"/>
+              </a:cxn>
+              <a:cxn ang="0">
+                <a:pos x="connsiteX9" y="connsiteY9"/>
+              </a:cxn>
+            </a:cxnLst>
+            <a:rect l="l" t="t" r="r" b="b"/>
+            <a:pathLst>
+              <a:path w="8284464" h="6858000">
+                <a:moveTo>
+                  <a:pt x="1818109" y="0"/>
+                </a:moveTo>
+                <a:lnTo>
+                  <a:pt x="6466355" y="0"/>
+                </a:lnTo>
+                <a:lnTo>
+                  <a:pt x="6620596" y="109683"/>
+                </a:lnTo>
+                <a:cubicBezTo>
+                  <a:pt x="7630666" y="865069"/>
+                  <a:pt x="8284464" y="2070683"/>
+                  <a:pt x="8284464" y="3429000"/>
+                </a:cubicBezTo>
+                <a:cubicBezTo>
+                  <a:pt x="8284464" y="4787317"/>
+                  <a:pt x="7630666" y="5992931"/>
+                  <a:pt x="6620596" y="6748318"/>
+                </a:cubicBezTo>
+                <a:lnTo>
+                  <a:pt x="6466355" y="6858000"/>
+                </a:lnTo>
+                <a:lnTo>
+                  <a:pt x="1818109" y="6858000"/>
+                </a:lnTo>
+                <a:lnTo>
+                  <a:pt x="1663869" y="6748318"/>
+                </a:lnTo>
+                <a:cubicBezTo>
+                  <a:pt x="653798" y="5992931"/>
+                  <a:pt x="0" y="4787317"/>
+                  <a:pt x="0" y="3429000"/>
+                </a:cubicBezTo>
+                <a:cubicBezTo>
+                  <a:pt x="0" y="2070683"/>
+                  <a:pt x="653798" y="865069"/>
+                  <a:pt x="1663869" y="109683"/>
+                </a:cubicBezTo>
+                <a:close/>
+              </a:path>
+            </a:pathLst>
+          </a:custGeom>
+          <a:solidFill>
+            <a:srgbClr val="FFFFFF">
+              <a:alpha val="80000"/>
+            </a:srgbClr>
+          </a:solidFill>
+          <a:ln>
+            <a:noFill/>
+          </a:ln>
         </p:spPr>
-        <p:txBody>
-          <a:bodyPr wrap="none" rtlCol="0">
-            <a:spAutoFit/>
+        <p:style>
+          <a:lnRef idx="2">
+            <a:schemeClr val="accent1">
+              <a:shade val="50000"/>
+            </a:schemeClr>
+          </a:lnRef>
+          <a:fillRef idx="1">
+            <a:schemeClr val="accent1"/>
+          </a:fillRef>
+          <a:effectRef idx="0">
+            <a:schemeClr val="accent1"/>
+          </a:effectRef>
+          <a:fontRef idx="minor">
+            <a:schemeClr val="lt1"/>
+          </a:fontRef>
+        </p:style>
+        <p:txBody>
+          <a:bodyPr wrap="square" rtlCol="0" anchor="ctr">
+            <a:noAutofit/>
           </a:bodyPr>
           <a:lstStyle/>
           <a:p>
-            <a:r>
-              <a:rPr lang="en-US" dirty="0">
-                <a:hlinkClick r:id="rId2"/>
-              </a:rPr>
-              <a:t>https://www.youtube.com/watch?v=KnWorqyDSLA</a:t>
-            </a:r>
-            <a:endParaRPr lang="en-US" dirty="0"/>
-          </a:p>
-          <a:p>
-            <a:endParaRPr lang="en-US" dirty="0"/>
-          </a:p>
-        </p:txBody>
-      </p:sp>
-      <p:pic>
-        <p:nvPicPr>
-          <p:cNvPr id="6" name="Picture 5" descr="A number and equation on a dark background&#10;&#10;AI-generated content may be incorrect.">
-            <a:extLst>
-              <a:ext uri="{FF2B5EF4-FFF2-40B4-BE49-F238E27FC236}">
-                <a16:creationId xmlns:a16="http://schemas.microsoft.com/office/drawing/2014/main" id="{9480E256-7359-151E-C9CD-7711F17BDB5B}"/>
-              </a:ext>
-            </a:extLst>
-          </p:cNvPr>
-          <p:cNvPicPr>
-            <a:picLocks noChangeAspect="1"/>
-          </p:cNvPicPr>
-          <p:nvPr/>
-        </p:nvPicPr>
-        <p:blipFill>
-          <a:blip r:embed="rId3">
-            <a:extLst>
-              <a:ext uri="{28A0092B-C50C-407E-A947-70E740481C1C}">
-                <a14:useLocalDpi xmlns:a14="http://schemas.microsoft.com/office/drawing/2010/main" val="0"/>
-              </a:ext>
-            </a:extLst>
-          </a:blip>
-          <a:stretch>
-            <a:fillRect/>
-          </a:stretch>
-        </p:blipFill>
+            <a:pPr algn="ctr"/>
+            <a:endParaRPr lang="en-US"/>
+          </a:p>
+        </p:txBody>
+      </p:sp>
+      <p:sp>
+        <p:nvSpPr>
+          <p:cNvPr id="9" name="Freeform: Shape 8">
+            <a:extLst>
+              <a:ext uri="{FF2B5EF4-FFF2-40B4-BE49-F238E27FC236}">
+                <a16:creationId xmlns:a16="http://schemas.microsoft.com/office/drawing/2014/main" id="{DF9AD32D-FF05-44F4-BD4D-9CEE89B71EB9}"/>
+              </a:ext>
+              <a:ext uri="{C183D7F6-B498-43B3-948B-1728B52AA6E4}">
+                <adec:decorative xmlns:adec="http://schemas.microsoft.com/office/drawing/2017/decorative" val="1"/>
+              </a:ext>
+            </a:extLst>
+          </p:cNvPr>
+          <p:cNvSpPr>
+            <a:spLocks noGrp="1" noRot="1" noChangeAspect="1" noMove="1" noResize="1" noEditPoints="1" noAdjustHandles="1" noChangeArrowheads="1" noChangeShapeType="1" noTextEdit="1"/>
+          </p:cNvSpPr>
+          <p:nvPr>
+            <p:extLst>
+              <p:ext uri="{386F3935-93C4-4BCD-93E2-E3B085C9AB24}">
+                <p16:designElem xmlns:p16="http://schemas.microsoft.com/office/powerpoint/2015/main" val="1"/>
+              </p:ext>
+            </p:extLst>
+          </p:nvPr>
+        </p:nvSpPr>
         <p:spPr>
           <a:xfrm>
-            <a:off x="627887" y="1381620"/>
-            <a:ext cx="10936226" cy="2657846"/>
+            <a:off x="2118360" y="0"/>
+            <a:ext cx="7955280" cy="6858000"/>
           </a:xfrm>
-          <a:prstGeom prst="rect">
+          <a:custGeom>
             <a:avLst/>
-          </a:prstGeom>
+            <a:gdLst>
+              <a:gd name="connsiteX0" fmla="*/ 1962423 w 7955280"/>
+              <a:gd name="connsiteY0" fmla="*/ 0 h 6858000"/>
+              <a:gd name="connsiteX1" fmla="*/ 5992858 w 7955280"/>
+              <a:gd name="connsiteY1" fmla="*/ 0 h 6858000"/>
+              <a:gd name="connsiteX2" fmla="*/ 6040191 w 7955280"/>
+              <a:gd name="connsiteY2" fmla="*/ 27216 h 6858000"/>
+              <a:gd name="connsiteX3" fmla="*/ 7955280 w 7955280"/>
+              <a:gd name="connsiteY3" fmla="*/ 3429000 h 6858000"/>
+              <a:gd name="connsiteX4" fmla="*/ 6040191 w 7955280"/>
+              <a:gd name="connsiteY4" fmla="*/ 6830784 h 6858000"/>
+              <a:gd name="connsiteX5" fmla="*/ 5992858 w 7955280"/>
+              <a:gd name="connsiteY5" fmla="*/ 6858000 h 6858000"/>
+              <a:gd name="connsiteX6" fmla="*/ 1962423 w 7955280"/>
+              <a:gd name="connsiteY6" fmla="*/ 6858000 h 6858000"/>
+              <a:gd name="connsiteX7" fmla="*/ 1915089 w 7955280"/>
+              <a:gd name="connsiteY7" fmla="*/ 6830784 h 6858000"/>
+              <a:gd name="connsiteX8" fmla="*/ 0 w 7955280"/>
+              <a:gd name="connsiteY8" fmla="*/ 3429000 h 6858000"/>
+              <a:gd name="connsiteX9" fmla="*/ 1915089 w 7955280"/>
+              <a:gd name="connsiteY9" fmla="*/ 27216 h 6858000"/>
+            </a:gdLst>
+            <a:ahLst/>
+            <a:cxnLst>
+              <a:cxn ang="0">
+                <a:pos x="connsiteX0" y="connsiteY0"/>
+              </a:cxn>
+              <a:cxn ang="0">
+                <a:pos x="connsiteX1" y="connsiteY1"/>
+              </a:cxn>
+              <a:cxn ang="0">
+                <a:pos x="connsiteX2" y="connsiteY2"/>
+              </a:cxn>
+              <a:cxn ang="0">
+                <a:pos x="connsiteX3" y="connsiteY3"/>
+              </a:cxn>
+              <a:cxn ang="0">
+                <a:pos x="connsiteX4" y="connsiteY4"/>
+              </a:cxn>
+              <a:cxn ang="0">
+                <a:pos x="connsiteX5" y="connsiteY5"/>
+              </a:cxn>
+              <a:cxn ang="0">
+                <a:pos x="connsiteX6" y="connsiteY6"/>
+              </a:cxn>
+              <a:cxn ang="0">
+                <a:pos x="connsiteX7" y="connsiteY7"/>
+              </a:cxn>
+              <a:cxn ang="0">
+                <a:pos x="connsiteX8" y="connsiteY8"/>
+              </a:cxn>
+              <a:cxn ang="0">
+                <a:pos x="connsiteX9" y="connsiteY9"/>
+              </a:cxn>
+            </a:cxnLst>
+            <a:rect l="l" t="t" r="r" b="b"/>
+            <a:pathLst>
+              <a:path w="7955280" h="6858000">
+                <a:moveTo>
+                  <a:pt x="1962423" y="0"/>
+                </a:moveTo>
+                <a:lnTo>
+                  <a:pt x="5992858" y="0"/>
+                </a:lnTo>
+                <a:lnTo>
+                  <a:pt x="6040191" y="27216"/>
+                </a:lnTo>
+                <a:cubicBezTo>
+                  <a:pt x="7188332" y="724844"/>
+                  <a:pt x="7955280" y="1987357"/>
+                  <a:pt x="7955280" y="3429000"/>
+                </a:cubicBezTo>
+                <a:cubicBezTo>
+                  <a:pt x="7955280" y="4870644"/>
+                  <a:pt x="7188332" y="6133157"/>
+                  <a:pt x="6040191" y="6830784"/>
+                </a:cubicBezTo>
+                <a:lnTo>
+                  <a:pt x="5992858" y="6858000"/>
+                </a:lnTo>
+                <a:lnTo>
+                  <a:pt x="1962423" y="6858000"/>
+                </a:lnTo>
+                <a:lnTo>
+                  <a:pt x="1915089" y="6830784"/>
+                </a:lnTo>
+                <a:cubicBezTo>
+                  <a:pt x="766948" y="6133157"/>
+                  <a:pt x="0" y="4870644"/>
+                  <a:pt x="0" y="3429000"/>
+                </a:cubicBezTo>
+                <a:cubicBezTo>
+                  <a:pt x="0" y="1987357"/>
+                  <a:pt x="766948" y="724844"/>
+                  <a:pt x="1915089" y="27216"/>
+                </a:cubicBezTo>
+                <a:close/>
+              </a:path>
+            </a:pathLst>
+          </a:custGeom>
+          <a:solidFill>
+            <a:schemeClr val="tx1"/>
+          </a:solidFill>
+          <a:ln>
+            <a:noFill/>
+          </a:ln>
         </p:spPr>
-      </p:pic>
+        <p:style>
+          <a:lnRef idx="2">
+            <a:schemeClr val="accent1">
+              <a:shade val="50000"/>
+            </a:schemeClr>
+          </a:lnRef>
+          <a:fillRef idx="1">
+            <a:schemeClr val="accent1"/>
+          </a:fillRef>
+          <a:effectRef idx="0">
+            <a:schemeClr val="accent1"/>
+          </a:effectRef>
+          <a:fontRef idx="minor">
+            <a:schemeClr val="lt1"/>
+          </a:fontRef>
+        </p:style>
+        <p:txBody>
+          <a:bodyPr wrap="square" rtlCol="0" anchor="ctr">
+            <a:noAutofit/>
+          </a:bodyPr>
+          <a:lstStyle/>
+          <a:p>
+            <a:pPr algn="ctr"/>
+            <a:endParaRPr lang="en-US"/>
+          </a:p>
+        </p:txBody>
+      </p:sp>
+      <p:sp>
+        <p:nvSpPr>
+          <p:cNvPr id="2" name="Title 1">
+            <a:extLst>
+              <a:ext uri="{FF2B5EF4-FFF2-40B4-BE49-F238E27FC236}">
+                <a16:creationId xmlns:a16="http://schemas.microsoft.com/office/drawing/2014/main" id="{41C67786-17B7-8D27-C5CE-3B25EA555BBC}"/>
+              </a:ext>
+            </a:extLst>
+          </p:cNvPr>
+          <p:cNvSpPr>
+            <a:spLocks noGrp="1"/>
+          </p:cNvSpPr>
+          <p:nvPr>
+            <p:ph type="title"/>
+          </p:nvPr>
+        </p:nvSpPr>
+        <p:spPr>
+          <a:xfrm>
+            <a:off x="2555631" y="1441938"/>
+            <a:ext cx="7080738" cy="3974124"/>
+          </a:xfrm>
+        </p:spPr>
+        <p:txBody>
+          <a:bodyPr vert="horz" lIns="91440" tIns="45720" rIns="91440" bIns="45720" rtlCol="0" anchor="ctr">
+            <a:normAutofit/>
+          </a:bodyPr>
+          <a:lstStyle/>
+          <a:p>
+            <a:pPr algn="ctr"/>
+            <a:r>
+              <a:rPr lang="en-US" sz="5400">
+                <a:solidFill>
+                  <a:schemeClr val="bg1">
+                    <a:lumMod val="95000"/>
+                    <a:lumOff val="5000"/>
+                  </a:schemeClr>
+                </a:solidFill>
+              </a:rPr>
+              <a:t>Example</a:t>
+            </a:r>
+          </a:p>
+        </p:txBody>
+      </p:sp>
     </p:spTree>
     <p:extLst>
       <p:ext uri="{BB962C8B-B14F-4D97-AF65-F5344CB8AC3E}">
-        <p14:creationId xmlns:p14="http://schemas.microsoft.com/office/powerpoint/2010/main" val="2785893426"/>
+        <p14:creationId xmlns:p14="http://schemas.microsoft.com/office/powerpoint/2010/main" val="208202109"/>
       </p:ext>
     </p:extLst>
   </p:cSld>
   <p:clrMapOvr>
-    <a:masterClrMapping/>
-  </p:clrMapOvr>
-</p:sld>
-</file>
-
-<file path=ppt/slides/slide16.xml><?xml version="1.0" encoding="utf-8"?>
-<p:sld xmlns:a="http://schemas.openxmlformats.org/drawingml/2006/main" xmlns:r="http://schemas.openxmlformats.org/officeDocument/2006/relationships" xmlns:p="http://schemas.openxmlformats.org/presentationml/2006/main">
-  <p:cSld>
-    <p:spTree>
-      <p:nvGrpSpPr>
-        <p:cNvPr id="1" name=""/>
-        <p:cNvGrpSpPr/>
-        <p:nvPr/>
-      </p:nvGrpSpPr>
-      <p:grpSpPr>
-        <a:xfrm>
-          <a:off x="0" y="0"/>
-          <a:ext cx="0" cy="0"/>
-          <a:chOff x="0" y="0"/>
-          <a:chExt cx="0" cy="0"/>
-        </a:xfrm>
-      </p:grpSpPr>
-      <p:sp>
-        <p:nvSpPr>
-          <p:cNvPr id="2" name="Title 1">
-            <a:extLst>
-              <a:ext uri="{FF2B5EF4-FFF2-40B4-BE49-F238E27FC236}">
-                <a16:creationId xmlns:a16="http://schemas.microsoft.com/office/drawing/2014/main" id="{0F89E9F8-2A3C-8195-F6DB-A0CF74A0B2F8}"/>
-              </a:ext>
-            </a:extLst>
-          </p:cNvPr>
-          <p:cNvSpPr>
-            <a:spLocks noGrp="1"/>
-          </p:cNvSpPr>
-          <p:nvPr>
-            <p:ph type="title"/>
-          </p:nvPr>
-        </p:nvSpPr>
-        <p:spPr/>
-        <p:txBody>
-          <a:bodyPr/>
-          <a:lstStyle/>
-          <a:p>
-            <a:endParaRPr lang="en-US"/>
-          </a:p>
-        </p:txBody>
-      </p:sp>
-      <p:sp>
-        <p:nvSpPr>
-          <p:cNvPr id="3" name="Content Placeholder 2">
-            <a:extLst>
-              <a:ext uri="{FF2B5EF4-FFF2-40B4-BE49-F238E27FC236}">
-                <a16:creationId xmlns:a16="http://schemas.microsoft.com/office/drawing/2014/main" id="{B8AD2CF8-3BE4-8C03-0370-5DD35F76B9F7}"/>
-              </a:ext>
-            </a:extLst>
-          </p:cNvPr>
-          <p:cNvSpPr>
-            <a:spLocks noGrp="1"/>
-          </p:cNvSpPr>
-          <p:nvPr>
-            <p:ph idx="1"/>
-          </p:nvPr>
-        </p:nvSpPr>
-        <p:spPr/>
-        <p:txBody>
-          <a:bodyPr/>
-          <a:lstStyle/>
-          <a:p>
-            <a:endParaRPr lang="en-US"/>
-          </a:p>
-        </p:txBody>
-      </p:sp>
-    </p:spTree>
-    <p:extLst>
-      <p:ext uri="{BB962C8B-B14F-4D97-AF65-F5344CB8AC3E}">
-        <p14:creationId xmlns:p14="http://schemas.microsoft.com/office/powerpoint/2010/main" val="3004034251"/>
-      </p:ext>
-    </p:extLst>
-  </p:cSld>
-  <p:clrMapOvr>
-    <a:masterClrMapping/>
+    <a:overrideClrMapping bg1="dk1" tx1="lt1" bg2="dk2" tx2="lt2" accent1="accent1" accent2="accent2" accent3="accent3" accent4="accent4" accent5="accent5" accent6="accent6" hlink="hlink" folHlink="folHlink"/>
   </p:clrMapOvr>
 </p:sld>
 </file>
@@ -9201,6 +9932,1605 @@
 </p:sld>
 </file>
 
+<file path=ppt/slides/slide20.xml><?xml version="1.0" encoding="utf-8"?>
+<p:sld xmlns:a="http://schemas.openxmlformats.org/drawingml/2006/main" xmlns:r="http://schemas.openxmlformats.org/officeDocument/2006/relationships" xmlns:p="http://schemas.openxmlformats.org/presentationml/2006/main">
+  <p:cSld>
+    <p:spTree>
+      <p:nvGrpSpPr>
+        <p:cNvPr id="1" name=""/>
+        <p:cNvGrpSpPr/>
+        <p:nvPr/>
+      </p:nvGrpSpPr>
+      <p:grpSpPr>
+        <a:xfrm>
+          <a:off x="0" y="0"/>
+          <a:ext cx="0" cy="0"/>
+          <a:chOff x="0" y="0"/>
+          <a:chExt cx="0" cy="0"/>
+        </a:xfrm>
+      </p:grpSpPr>
+      <mc:AlternateContent xmlns:mc="http://schemas.openxmlformats.org/markup-compatibility/2006">
+        <mc:Choice xmlns:a14="http://schemas.microsoft.com/office/drawing/2010/main" Requires="a14">
+          <p:sp>
+            <p:nvSpPr>
+              <p:cNvPr id="4" name="TextBox 3">
+                <a:extLst>
+                  <a:ext uri="{FF2B5EF4-FFF2-40B4-BE49-F238E27FC236}">
+                    <a16:creationId xmlns:a16="http://schemas.microsoft.com/office/drawing/2014/main" id="{0E3CB8B0-DFC3-4B9B-1476-5C7608FB93A4}"/>
+                  </a:ext>
+                </a:extLst>
+              </p:cNvPr>
+              <p:cNvSpPr txBox="1"/>
+              <p:nvPr/>
+            </p:nvSpPr>
+            <p:spPr>
+              <a:xfrm>
+                <a:off x="816428" y="838200"/>
+                <a:ext cx="3217099" cy="553998"/>
+              </a:xfrm>
+              <a:prstGeom prst="rect">
+                <a:avLst/>
+              </a:prstGeom>
+              <a:noFill/>
+            </p:spPr>
+            <p:txBody>
+              <a:bodyPr wrap="none" lIns="0" tIns="0" rIns="0" bIns="0" rtlCol="0">
+                <a:spAutoFit/>
+              </a:bodyPr>
+              <a:lstStyle/>
+              <a:p>
+                <a14:m>
+                  <m:oMathPara xmlns:m="http://schemas.openxmlformats.org/officeDocument/2006/math">
+                    <m:oMathParaPr>
+                      <m:jc m:val="centerGroup"/>
+                    </m:oMathParaPr>
+                    <m:oMath xmlns:m="http://schemas.openxmlformats.org/officeDocument/2006/math">
+                      <m:r>
+                        <a:rPr lang="en-US" sz="3600" b="0" i="1" smtClean="0">
+                          <a:latin typeface="Cambria Math" panose="02040503050406030204" pitchFamily="18" charset="0"/>
+                        </a:rPr>
+                        <m:t>𝑐𝑜𝑖𝑛𝑠</m:t>
+                      </m:r>
+                      <m:r>
+                        <a:rPr lang="en-US" sz="3600" b="0" i="1" smtClean="0">
+                          <a:latin typeface="Cambria Math" panose="02040503050406030204" pitchFamily="18" charset="0"/>
+                        </a:rPr>
+                        <m:t>=[1, 2, 5]</m:t>
+                      </m:r>
+                    </m:oMath>
+                  </m:oMathPara>
+                </a14:m>
+                <a:endParaRPr lang="en-US" sz="3600" dirty="0"/>
+              </a:p>
+            </p:txBody>
+          </p:sp>
+        </mc:Choice>
+        <mc:Fallback>
+          <p:sp>
+            <p:nvSpPr>
+              <p:cNvPr id="4" name="TextBox 3">
+                <a:extLst>
+                  <a:ext uri="{FF2B5EF4-FFF2-40B4-BE49-F238E27FC236}">
+                    <a16:creationId xmlns:a16="http://schemas.microsoft.com/office/drawing/2014/main" id="{0E3CB8B0-DFC3-4B9B-1476-5C7608FB93A4}"/>
+                  </a:ext>
+                </a:extLst>
+              </p:cNvPr>
+              <p:cNvSpPr txBox="1">
+                <a:spLocks noRot="1" noChangeAspect="1" noMove="1" noResize="1" noEditPoints="1" noAdjustHandles="1" noChangeArrowheads="1" noChangeShapeType="1" noTextEdit="1"/>
+              </p:cNvSpPr>
+              <p:nvPr/>
+            </p:nvSpPr>
+            <p:spPr>
+              <a:xfrm>
+                <a:off x="816428" y="838200"/>
+                <a:ext cx="3217099" cy="553998"/>
+              </a:xfrm>
+              <a:prstGeom prst="rect">
+                <a:avLst/>
+              </a:prstGeom>
+              <a:blipFill>
+                <a:blip r:embed="rId2"/>
+                <a:stretch>
+                  <a:fillRect/>
+                </a:stretch>
+              </a:blipFill>
+            </p:spPr>
+            <p:txBody>
+              <a:bodyPr/>
+              <a:lstStyle/>
+              <a:p>
+                <a:r>
+                  <a:rPr lang="en-US">
+                    <a:noFill/>
+                  </a:rPr>
+                  <a:t> </a:t>
+                </a:r>
+              </a:p>
+            </p:txBody>
+          </p:sp>
+        </mc:Fallback>
+      </mc:AlternateContent>
+      <mc:AlternateContent xmlns:mc="http://schemas.openxmlformats.org/markup-compatibility/2006">
+        <mc:Choice xmlns:a14="http://schemas.microsoft.com/office/drawing/2010/main" Requires="a14">
+          <p:sp>
+            <p:nvSpPr>
+              <p:cNvPr id="5" name="TextBox 4">
+                <a:extLst>
+                  <a:ext uri="{FF2B5EF4-FFF2-40B4-BE49-F238E27FC236}">
+                    <a16:creationId xmlns:a16="http://schemas.microsoft.com/office/drawing/2014/main" id="{9DCF3032-4081-4A11-B275-840314803904}"/>
+                  </a:ext>
+                </a:extLst>
+              </p:cNvPr>
+              <p:cNvSpPr txBox="1"/>
+              <p:nvPr/>
+            </p:nvSpPr>
+            <p:spPr>
+              <a:xfrm>
+                <a:off x="816427" y="1567543"/>
+                <a:ext cx="4281750" cy="553998"/>
+              </a:xfrm>
+              <a:prstGeom prst="rect">
+                <a:avLst/>
+              </a:prstGeom>
+              <a:noFill/>
+            </p:spPr>
+            <p:txBody>
+              <a:bodyPr wrap="none" lIns="0" tIns="0" rIns="0" bIns="0" rtlCol="0">
+                <a:spAutoFit/>
+              </a:bodyPr>
+              <a:lstStyle/>
+              <a:p>
+                <a14:m>
+                  <m:oMathPara xmlns:m="http://schemas.openxmlformats.org/officeDocument/2006/math">
+                    <m:oMathParaPr>
+                      <m:jc m:val="centerGroup"/>
+                    </m:oMathParaPr>
+                    <m:oMath xmlns:m="http://schemas.openxmlformats.org/officeDocument/2006/math">
+                      <m:r>
+                        <a:rPr lang="en-US" sz="3600" b="0" i="1" smtClean="0">
+                          <a:latin typeface="Cambria Math" panose="02040503050406030204" pitchFamily="18" charset="0"/>
+                        </a:rPr>
+                        <m:t>𝑡𝑎𝑟𝑔𝑒𝑡</m:t>
+                      </m:r>
+                      <m:r>
+                        <a:rPr lang="en-US" sz="3600" b="0" i="1" smtClean="0">
+                          <a:latin typeface="Cambria Math" panose="02040503050406030204" pitchFamily="18" charset="0"/>
+                        </a:rPr>
+                        <m:t> </m:t>
+                      </m:r>
+                      <m:r>
+                        <a:rPr lang="en-US" sz="3600" b="0" i="1" smtClean="0">
+                          <a:latin typeface="Cambria Math" panose="02040503050406030204" pitchFamily="18" charset="0"/>
+                        </a:rPr>
+                        <m:t>𝑎𝑚𝑜𝑢𝑛𝑡</m:t>
+                      </m:r>
+                      <m:r>
+                        <a:rPr lang="en-US" sz="3600" b="0" i="1" smtClean="0">
+                          <a:latin typeface="Cambria Math" panose="02040503050406030204" pitchFamily="18" charset="0"/>
+                        </a:rPr>
+                        <m:t>=11</m:t>
+                      </m:r>
+                    </m:oMath>
+                  </m:oMathPara>
+                </a14:m>
+                <a:endParaRPr lang="en-US" sz="3600" dirty="0"/>
+              </a:p>
+            </p:txBody>
+          </p:sp>
+        </mc:Choice>
+        <mc:Fallback>
+          <p:sp>
+            <p:nvSpPr>
+              <p:cNvPr id="5" name="TextBox 4">
+                <a:extLst>
+                  <a:ext uri="{FF2B5EF4-FFF2-40B4-BE49-F238E27FC236}">
+                    <a16:creationId xmlns:a16="http://schemas.microsoft.com/office/drawing/2014/main" id="{9DCF3032-4081-4A11-B275-840314803904}"/>
+                  </a:ext>
+                </a:extLst>
+              </p:cNvPr>
+              <p:cNvSpPr txBox="1">
+                <a:spLocks noRot="1" noChangeAspect="1" noMove="1" noResize="1" noEditPoints="1" noAdjustHandles="1" noChangeArrowheads="1" noChangeShapeType="1" noTextEdit="1"/>
+              </p:cNvSpPr>
+              <p:nvPr/>
+            </p:nvSpPr>
+            <p:spPr>
+              <a:xfrm>
+                <a:off x="816427" y="1567543"/>
+                <a:ext cx="4281750" cy="553998"/>
+              </a:xfrm>
+              <a:prstGeom prst="rect">
+                <a:avLst/>
+              </a:prstGeom>
+              <a:blipFill>
+                <a:blip r:embed="rId3"/>
+                <a:stretch>
+                  <a:fillRect/>
+                </a:stretch>
+              </a:blipFill>
+            </p:spPr>
+            <p:txBody>
+              <a:bodyPr/>
+              <a:lstStyle/>
+              <a:p>
+                <a:r>
+                  <a:rPr lang="en-US">
+                    <a:noFill/>
+                  </a:rPr>
+                  <a:t> </a:t>
+                </a:r>
+              </a:p>
+            </p:txBody>
+          </p:sp>
+        </mc:Fallback>
+      </mc:AlternateContent>
+      <p:sp>
+        <p:nvSpPr>
+          <p:cNvPr id="6" name="TextBox 5">
+            <a:extLst>
+              <a:ext uri="{FF2B5EF4-FFF2-40B4-BE49-F238E27FC236}">
+                <a16:creationId xmlns:a16="http://schemas.microsoft.com/office/drawing/2014/main" id="{B7245000-63F0-B8CF-CDE5-B708A2D1855B}"/>
+              </a:ext>
+            </a:extLst>
+          </p:cNvPr>
+          <p:cNvSpPr txBox="1"/>
+          <p:nvPr/>
+        </p:nvSpPr>
+        <p:spPr>
+          <a:xfrm>
+            <a:off x="685800" y="191869"/>
+            <a:ext cx="5079980" cy="646331"/>
+          </a:xfrm>
+          <a:prstGeom prst="rect">
+            <a:avLst/>
+          </a:prstGeom>
+          <a:noFill/>
+        </p:spPr>
+        <p:txBody>
+          <a:bodyPr wrap="none" rtlCol="0">
+            <a:spAutoFit/>
+          </a:bodyPr>
+          <a:lstStyle/>
+          <a:p>
+            <a:r>
+              <a:rPr lang="en-US" dirty="0">
+                <a:hlinkClick r:id="rId4"/>
+              </a:rPr>
+              <a:t>https://www.youtube.com/watch?v=jgiZlGzXMBw</a:t>
+            </a:r>
+            <a:endParaRPr lang="en-US" dirty="0"/>
+          </a:p>
+          <a:p>
+            <a:endParaRPr lang="en-US" dirty="0"/>
+          </a:p>
+        </p:txBody>
+      </p:sp>
+    </p:spTree>
+    <p:extLst>
+      <p:ext uri="{BB962C8B-B14F-4D97-AF65-F5344CB8AC3E}">
+        <p14:creationId xmlns:p14="http://schemas.microsoft.com/office/powerpoint/2010/main" val="1563291196"/>
+      </p:ext>
+    </p:extLst>
+  </p:cSld>
+  <p:clrMapOvr>
+    <a:masterClrMapping/>
+  </p:clrMapOvr>
+</p:sld>
+</file>
+
+<file path=ppt/slides/slide21.xml><?xml version="1.0" encoding="utf-8"?>
+<p:sld xmlns:a="http://schemas.openxmlformats.org/drawingml/2006/main" xmlns:r="http://schemas.openxmlformats.org/officeDocument/2006/relationships" xmlns:p="http://schemas.openxmlformats.org/presentationml/2006/main">
+  <p:cSld>
+    <p:bg>
+      <p:bgPr>
+        <a:solidFill>
+          <a:schemeClr val="bg1"/>
+        </a:solidFill>
+        <a:effectLst/>
+      </p:bgPr>
+    </p:bg>
+    <p:spTree>
+      <p:nvGrpSpPr>
+        <p:cNvPr id="1" name=""/>
+        <p:cNvGrpSpPr/>
+        <p:nvPr/>
+      </p:nvGrpSpPr>
+      <p:grpSpPr>
+        <a:xfrm>
+          <a:off x="0" y="0"/>
+          <a:ext cx="0" cy="0"/>
+          <a:chOff x="0" y="0"/>
+          <a:chExt cx="0" cy="0"/>
+        </a:xfrm>
+      </p:grpSpPr>
+      <p:sp useBgFill="1">
+        <p:nvSpPr>
+          <p:cNvPr id="9" name="Rectangle 8">
+            <a:extLst>
+              <a:ext uri="{FF2B5EF4-FFF2-40B4-BE49-F238E27FC236}">
+                <a16:creationId xmlns:a16="http://schemas.microsoft.com/office/drawing/2014/main" id="{C1DD1A8A-57D5-4A81-AD04-532B043C5611}"/>
+              </a:ext>
+              <a:ext uri="{C183D7F6-B498-43B3-948B-1728B52AA6E4}">
+                <adec:decorative xmlns:adec="http://schemas.microsoft.com/office/drawing/2017/decorative" val="1"/>
+              </a:ext>
+            </a:extLst>
+          </p:cNvPr>
+          <p:cNvSpPr>
+            <a:spLocks noGrp="1" noRot="1" noChangeAspect="1" noMove="1" noResize="1" noEditPoints="1" noAdjustHandles="1" noChangeArrowheads="1" noChangeShapeType="1" noTextEdit="1"/>
+          </p:cNvSpPr>
+          <p:nvPr>
+            <p:extLst>
+              <p:ext uri="{386F3935-93C4-4BCD-93E2-E3B085C9AB24}">
+                <p16:designElem xmlns:p16="http://schemas.microsoft.com/office/powerpoint/2015/main" val="1"/>
+              </p:ext>
+            </p:extLst>
+          </p:nvPr>
+        </p:nvSpPr>
+        <p:spPr>
+          <a:xfrm>
+            <a:off x="-1" y="0"/>
+            <a:ext cx="12188952" cy="6858000"/>
+          </a:xfrm>
+          <a:prstGeom prst="rect">
+            <a:avLst/>
+          </a:prstGeom>
+          <a:ln>
+            <a:noFill/>
+          </a:ln>
+        </p:spPr>
+        <p:style>
+          <a:lnRef idx="2">
+            <a:schemeClr val="accent1">
+              <a:shade val="50000"/>
+            </a:schemeClr>
+          </a:lnRef>
+          <a:fillRef idx="1">
+            <a:schemeClr val="accent1"/>
+          </a:fillRef>
+          <a:effectRef idx="0">
+            <a:schemeClr val="accent1"/>
+          </a:effectRef>
+          <a:fontRef idx="minor">
+            <a:schemeClr val="lt1"/>
+          </a:fontRef>
+        </p:style>
+        <p:txBody>
+          <a:bodyPr rtlCol="0" anchor="ctr"/>
+          <a:lstStyle/>
+          <a:p>
+            <a:pPr algn="ctr"/>
+            <a:endParaRPr lang="en-US"/>
+          </a:p>
+        </p:txBody>
+      </p:sp>
+      <p:pic>
+        <p:nvPicPr>
+          <p:cNvPr id="5" name="Picture 4" descr="A group of children coloring on a large white paper&#10;&#10;AI-generated content may be incorrect.">
+            <a:extLst>
+              <a:ext uri="{FF2B5EF4-FFF2-40B4-BE49-F238E27FC236}">
+                <a16:creationId xmlns:a16="http://schemas.microsoft.com/office/drawing/2014/main" id="{17C36405-07CD-B97B-C878-E91F0ED8E13A}"/>
+              </a:ext>
+            </a:extLst>
+          </p:cNvPr>
+          <p:cNvPicPr>
+            <a:picLocks noChangeAspect="1"/>
+          </p:cNvPicPr>
+          <p:nvPr/>
+        </p:nvPicPr>
+        <p:blipFill>
+          <a:blip r:embed="rId2"/>
+          <a:srcRect/>
+          <a:stretch>
+            <a:fillRect/>
+          </a:stretch>
+        </p:blipFill>
+        <p:spPr>
+          <a:xfrm>
+            <a:off x="-3047" y="10"/>
+            <a:ext cx="12191999" cy="6857990"/>
+          </a:xfrm>
+          <a:prstGeom prst="rect">
+            <a:avLst/>
+          </a:prstGeom>
+        </p:spPr>
+      </p:pic>
+      <p:sp>
+        <p:nvSpPr>
+          <p:cNvPr id="11" name="Rectangle 10">
+            <a:extLst>
+              <a:ext uri="{FF2B5EF4-FFF2-40B4-BE49-F238E27FC236}">
+                <a16:creationId xmlns:a16="http://schemas.microsoft.com/office/drawing/2014/main" id="{007891EC-4501-44ED-A8C8-B11B6DB767AB}"/>
+              </a:ext>
+              <a:ext uri="{C183D7F6-B498-43B3-948B-1728B52AA6E4}">
+                <adec:decorative xmlns:adec="http://schemas.microsoft.com/office/drawing/2017/decorative" val="1"/>
+              </a:ext>
+            </a:extLst>
+          </p:cNvPr>
+          <p:cNvSpPr>
+            <a:spLocks noGrp="1" noRot="1" noChangeAspect="1" noMove="1" noResize="1" noEditPoints="1" noAdjustHandles="1" noChangeArrowheads="1" noChangeShapeType="1" noTextEdit="1"/>
+          </p:cNvSpPr>
+          <p:nvPr>
+            <p:extLst>
+              <p:ext uri="{386F3935-93C4-4BCD-93E2-E3B085C9AB24}">
+                <p16:designElem xmlns:p16="http://schemas.microsoft.com/office/powerpoint/2015/main" val="1"/>
+              </p:ext>
+            </p:extLst>
+          </p:nvPr>
+        </p:nvSpPr>
+        <p:spPr>
+          <a:xfrm>
+            <a:off x="0" y="2207602"/>
+            <a:ext cx="12191999" cy="3162146"/>
+          </a:xfrm>
+          <a:prstGeom prst="rect">
+            <a:avLst/>
+          </a:prstGeom>
+          <a:gradFill flip="none" rotWithShape="1">
+            <a:gsLst>
+              <a:gs pos="0">
+                <a:srgbClr val="000000">
+                  <a:alpha val="0"/>
+                </a:srgbClr>
+              </a:gs>
+              <a:gs pos="25000">
+                <a:srgbClr val="000000">
+                  <a:alpha val="15000"/>
+                </a:srgbClr>
+              </a:gs>
+              <a:gs pos="75000">
+                <a:srgbClr val="000000">
+                  <a:alpha val="15000"/>
+                </a:srgbClr>
+              </a:gs>
+              <a:gs pos="50000">
+                <a:srgbClr val="000000">
+                  <a:alpha val="30000"/>
+                </a:srgbClr>
+              </a:gs>
+              <a:gs pos="100000">
+                <a:srgbClr val="000000">
+                  <a:alpha val="0"/>
+                </a:srgbClr>
+              </a:gs>
+            </a:gsLst>
+            <a:lin ang="16200000" scaled="1"/>
+            <a:tileRect/>
+          </a:gradFill>
+          <a:ln>
+            <a:noFill/>
+          </a:ln>
+        </p:spPr>
+        <p:style>
+          <a:lnRef idx="2">
+            <a:schemeClr val="accent1">
+              <a:shade val="50000"/>
+            </a:schemeClr>
+          </a:lnRef>
+          <a:fillRef idx="1">
+            <a:schemeClr val="accent1"/>
+          </a:fillRef>
+          <a:effectRef idx="0">
+            <a:schemeClr val="accent1"/>
+          </a:effectRef>
+          <a:fontRef idx="minor">
+            <a:schemeClr val="lt1"/>
+          </a:fontRef>
+        </p:style>
+        <p:txBody>
+          <a:bodyPr rtlCol="0" anchor="ctr"/>
+          <a:lstStyle/>
+          <a:p>
+            <a:pPr algn="ctr"/>
+            <a:endParaRPr lang="en-US"/>
+          </a:p>
+        </p:txBody>
+      </p:sp>
+      <p:sp>
+        <p:nvSpPr>
+          <p:cNvPr id="2" name="Title 1">
+            <a:extLst>
+              <a:ext uri="{FF2B5EF4-FFF2-40B4-BE49-F238E27FC236}">
+                <a16:creationId xmlns:a16="http://schemas.microsoft.com/office/drawing/2014/main" id="{E879FBD9-ADD4-F0D7-F7C3-0D5CDF62740B}"/>
+              </a:ext>
+            </a:extLst>
+          </p:cNvPr>
+          <p:cNvSpPr>
+            <a:spLocks noGrp="1"/>
+          </p:cNvSpPr>
+          <p:nvPr>
+            <p:ph type="title"/>
+          </p:nvPr>
+        </p:nvSpPr>
+        <p:spPr>
+          <a:xfrm>
+            <a:off x="1097280" y="325550"/>
+            <a:ext cx="10058400" cy="3574778"/>
+          </a:xfrm>
+          <a:effectLst>
+            <a:outerShdw blurRad="50800" dist="38100" dir="2700000" algn="tl" rotWithShape="0">
+              <a:prstClr val="black">
+                <a:alpha val="40000"/>
+              </a:prstClr>
+            </a:outerShdw>
+          </a:effectLst>
+        </p:spPr>
+        <p:txBody>
+          <a:bodyPr vert="horz" lIns="91440" tIns="45720" rIns="91440" bIns="45720" rtlCol="0" anchor="b">
+            <a:normAutofit/>
+          </a:bodyPr>
+          <a:lstStyle/>
+          <a:p>
+            <a:pPr algn="ctr"/>
+            <a:r>
+              <a:rPr lang="en-US" sz="5200">
+                <a:solidFill>
+                  <a:srgbClr val="FFFFFF"/>
+                </a:solidFill>
+              </a:rPr>
+              <a:t>It’s drawing time!</a:t>
+            </a:r>
+          </a:p>
+        </p:txBody>
+      </p:sp>
+    </p:spTree>
+    <p:extLst>
+      <p:ext uri="{BB962C8B-B14F-4D97-AF65-F5344CB8AC3E}">
+        <p14:creationId xmlns:p14="http://schemas.microsoft.com/office/powerpoint/2010/main" val="2154885148"/>
+      </p:ext>
+    </p:extLst>
+  </p:cSld>
+  <p:clrMapOvr>
+    <a:masterClrMapping/>
+  </p:clrMapOvr>
+</p:sld>
+</file>
+
+<file path=ppt/slides/slide22.xml><?xml version="1.0" encoding="utf-8"?>
+<p:sld xmlns:a="http://schemas.openxmlformats.org/drawingml/2006/main" xmlns:r="http://schemas.openxmlformats.org/officeDocument/2006/relationships" xmlns:p="http://schemas.openxmlformats.org/presentationml/2006/main">
+  <p:cSld>
+    <p:spTree>
+      <p:nvGrpSpPr>
+        <p:cNvPr id="1" name=""/>
+        <p:cNvGrpSpPr/>
+        <p:nvPr/>
+      </p:nvGrpSpPr>
+      <p:grpSpPr>
+        <a:xfrm>
+          <a:off x="0" y="0"/>
+          <a:ext cx="0" cy="0"/>
+          <a:chOff x="0" y="0"/>
+          <a:chExt cx="0" cy="0"/>
+        </a:xfrm>
+      </p:grpSpPr>
+      <p:sp>
+        <p:nvSpPr>
+          <p:cNvPr id="4" name="TextBox 3">
+            <a:extLst>
+              <a:ext uri="{FF2B5EF4-FFF2-40B4-BE49-F238E27FC236}">
+                <a16:creationId xmlns:a16="http://schemas.microsoft.com/office/drawing/2014/main" id="{F9A826B7-5B7F-F2C1-16F7-53B040506C50}"/>
+              </a:ext>
+            </a:extLst>
+          </p:cNvPr>
+          <p:cNvSpPr txBox="1"/>
+          <p:nvPr/>
+        </p:nvSpPr>
+        <p:spPr>
+          <a:xfrm>
+            <a:off x="1175657" y="435429"/>
+            <a:ext cx="5233292" cy="646331"/>
+          </a:xfrm>
+          <a:prstGeom prst="rect">
+            <a:avLst/>
+          </a:prstGeom>
+          <a:noFill/>
+        </p:spPr>
+        <p:txBody>
+          <a:bodyPr wrap="none" rtlCol="0">
+            <a:spAutoFit/>
+          </a:bodyPr>
+          <a:lstStyle/>
+          <a:p>
+            <a:r>
+              <a:rPr lang="en-US" dirty="0">
+                <a:hlinkClick r:id="rId2"/>
+              </a:rPr>
+              <a:t>https://www.youtube.com/watch?v=KnWorqyDSLA</a:t>
+            </a:r>
+            <a:endParaRPr lang="en-US" dirty="0"/>
+          </a:p>
+          <a:p>
+            <a:endParaRPr lang="en-US" dirty="0"/>
+          </a:p>
+        </p:txBody>
+      </p:sp>
+      <p:pic>
+        <p:nvPicPr>
+          <p:cNvPr id="6" name="Picture 5" descr="A number and equation on a dark background&#10;&#10;AI-generated content may be incorrect.">
+            <a:extLst>
+              <a:ext uri="{FF2B5EF4-FFF2-40B4-BE49-F238E27FC236}">
+                <a16:creationId xmlns:a16="http://schemas.microsoft.com/office/drawing/2014/main" id="{9480E256-7359-151E-C9CD-7711F17BDB5B}"/>
+              </a:ext>
+            </a:extLst>
+          </p:cNvPr>
+          <p:cNvPicPr>
+            <a:picLocks noChangeAspect="1"/>
+          </p:cNvPicPr>
+          <p:nvPr/>
+        </p:nvPicPr>
+        <p:blipFill>
+          <a:blip r:embed="rId3">
+            <a:extLst>
+              <a:ext uri="{28A0092B-C50C-407E-A947-70E740481C1C}">
+                <a14:useLocalDpi xmlns:a14="http://schemas.microsoft.com/office/drawing/2010/main" val="0"/>
+              </a:ext>
+            </a:extLst>
+          </a:blip>
+          <a:stretch>
+            <a:fillRect/>
+          </a:stretch>
+        </p:blipFill>
+        <p:spPr>
+          <a:xfrm>
+            <a:off x="627887" y="1381620"/>
+            <a:ext cx="10936226" cy="2657846"/>
+          </a:xfrm>
+          <a:prstGeom prst="rect">
+            <a:avLst/>
+          </a:prstGeom>
+        </p:spPr>
+      </p:pic>
+    </p:spTree>
+    <p:extLst>
+      <p:ext uri="{BB962C8B-B14F-4D97-AF65-F5344CB8AC3E}">
+        <p14:creationId xmlns:p14="http://schemas.microsoft.com/office/powerpoint/2010/main" val="2785893426"/>
+      </p:ext>
+    </p:extLst>
+  </p:cSld>
+  <p:clrMapOvr>
+    <a:masterClrMapping/>
+  </p:clrMapOvr>
+</p:sld>
+</file>
+
+<file path=ppt/slides/slide23.xml><?xml version="1.0" encoding="utf-8"?>
+<p:sld xmlns:a="http://schemas.openxmlformats.org/drawingml/2006/main" xmlns:r="http://schemas.openxmlformats.org/officeDocument/2006/relationships" xmlns:p="http://schemas.openxmlformats.org/presentationml/2006/main">
+  <p:cSld>
+    <p:spTree>
+      <p:nvGrpSpPr>
+        <p:cNvPr id="1" name="">
+          <a:extLst>
+            <a:ext uri="{FF2B5EF4-FFF2-40B4-BE49-F238E27FC236}">
+              <a16:creationId xmlns:a16="http://schemas.microsoft.com/office/drawing/2014/main" id="{9A83F31B-DF53-1341-975D-11A7B1DF33AF}"/>
+            </a:ext>
+          </a:extLst>
+        </p:cNvPr>
+        <p:cNvGrpSpPr/>
+        <p:nvPr/>
+      </p:nvGrpSpPr>
+      <p:grpSpPr>
+        <a:xfrm>
+          <a:off x="0" y="0"/>
+          <a:ext cx="0" cy="0"/>
+          <a:chOff x="0" y="0"/>
+          <a:chExt cx="0" cy="0"/>
+        </a:xfrm>
+      </p:grpSpPr>
+      <p:sp>
+        <p:nvSpPr>
+          <p:cNvPr id="4" name="TextBox 3">
+            <a:extLst>
+              <a:ext uri="{FF2B5EF4-FFF2-40B4-BE49-F238E27FC236}">
+                <a16:creationId xmlns:a16="http://schemas.microsoft.com/office/drawing/2014/main" id="{52443E65-D43F-FF8F-8A3A-22C2064A3B09}"/>
+              </a:ext>
+            </a:extLst>
+          </p:cNvPr>
+          <p:cNvSpPr txBox="1"/>
+          <p:nvPr/>
+        </p:nvSpPr>
+        <p:spPr>
+          <a:xfrm>
+            <a:off x="1175657" y="435429"/>
+            <a:ext cx="5233292" cy="646331"/>
+          </a:xfrm>
+          <a:prstGeom prst="rect">
+            <a:avLst/>
+          </a:prstGeom>
+          <a:noFill/>
+        </p:spPr>
+        <p:txBody>
+          <a:bodyPr wrap="none" rtlCol="0">
+            <a:spAutoFit/>
+          </a:bodyPr>
+          <a:lstStyle/>
+          <a:p>
+            <a:r>
+              <a:rPr lang="en-US">
+                <a:hlinkClick r:id="rId2"/>
+              </a:rPr>
+              <a:t>https://www.youtube.com/watch?v=KnWorqyDSLA</a:t>
+            </a:r>
+            <a:endParaRPr lang="en-US"/>
+          </a:p>
+          <a:p>
+            <a:endParaRPr lang="en-US" dirty="0"/>
+          </a:p>
+        </p:txBody>
+      </p:sp>
+      <p:pic>
+        <p:nvPicPr>
+          <p:cNvPr id="6" name="Picture 5">
+            <a:extLst>
+              <a:ext uri="{FF2B5EF4-FFF2-40B4-BE49-F238E27FC236}">
+                <a16:creationId xmlns:a16="http://schemas.microsoft.com/office/drawing/2014/main" id="{D2B90388-2EAA-72E6-F464-E2DC37474EFD}"/>
+              </a:ext>
+            </a:extLst>
+          </p:cNvPr>
+          <p:cNvPicPr>
+            <a:picLocks noChangeAspect="1"/>
+          </p:cNvPicPr>
+          <p:nvPr/>
+        </p:nvPicPr>
+        <p:blipFill>
+          <a:blip r:embed="rId3">
+            <a:extLst>
+              <a:ext uri="{28A0092B-C50C-407E-A947-70E740481C1C}">
+                <a14:useLocalDpi xmlns:a14="http://schemas.microsoft.com/office/drawing/2010/main" val="0"/>
+              </a:ext>
+            </a:extLst>
+          </a:blip>
+          <a:srcRect/>
+          <a:stretch/>
+        </p:blipFill>
+        <p:spPr>
+          <a:xfrm>
+            <a:off x="947057" y="983789"/>
+            <a:ext cx="10297885" cy="5525696"/>
+          </a:xfrm>
+          <a:prstGeom prst="rect">
+            <a:avLst/>
+          </a:prstGeom>
+        </p:spPr>
+      </p:pic>
+    </p:spTree>
+    <p:extLst>
+      <p:ext uri="{BB962C8B-B14F-4D97-AF65-F5344CB8AC3E}">
+        <p14:creationId xmlns:p14="http://schemas.microsoft.com/office/powerpoint/2010/main" val="62513284"/>
+      </p:ext>
+    </p:extLst>
+  </p:cSld>
+  <p:clrMapOvr>
+    <a:masterClrMapping/>
+  </p:clrMapOvr>
+</p:sld>
+</file>
+
+<file path=ppt/slides/slide24.xml><?xml version="1.0" encoding="utf-8"?>
+<p:sld xmlns:a="http://schemas.openxmlformats.org/drawingml/2006/main" xmlns:r="http://schemas.openxmlformats.org/officeDocument/2006/relationships" xmlns:p="http://schemas.openxmlformats.org/presentationml/2006/main">
+  <p:cSld>
+    <p:spTree>
+      <p:nvGrpSpPr>
+        <p:cNvPr id="1" name="">
+          <a:extLst>
+            <a:ext uri="{FF2B5EF4-FFF2-40B4-BE49-F238E27FC236}">
+              <a16:creationId xmlns:a16="http://schemas.microsoft.com/office/drawing/2014/main" id="{F7CD5DB9-346F-CB80-AA93-4CB59321BDBD}"/>
+            </a:ext>
+          </a:extLst>
+        </p:cNvPr>
+        <p:cNvGrpSpPr/>
+        <p:nvPr/>
+      </p:nvGrpSpPr>
+      <p:grpSpPr>
+        <a:xfrm>
+          <a:off x="0" y="0"/>
+          <a:ext cx="0" cy="0"/>
+          <a:chOff x="0" y="0"/>
+          <a:chExt cx="0" cy="0"/>
+        </a:xfrm>
+      </p:grpSpPr>
+      <p:sp>
+        <p:nvSpPr>
+          <p:cNvPr id="4" name="TextBox 3">
+            <a:extLst>
+              <a:ext uri="{FF2B5EF4-FFF2-40B4-BE49-F238E27FC236}">
+                <a16:creationId xmlns:a16="http://schemas.microsoft.com/office/drawing/2014/main" id="{0C077FBD-D741-EEFF-8609-F3B9D6B001C7}"/>
+              </a:ext>
+            </a:extLst>
+          </p:cNvPr>
+          <p:cNvSpPr txBox="1"/>
+          <p:nvPr/>
+        </p:nvSpPr>
+        <p:spPr>
+          <a:xfrm>
+            <a:off x="1175657" y="435429"/>
+            <a:ext cx="5233292" cy="646331"/>
+          </a:xfrm>
+          <a:prstGeom prst="rect">
+            <a:avLst/>
+          </a:prstGeom>
+          <a:noFill/>
+        </p:spPr>
+        <p:txBody>
+          <a:bodyPr wrap="none" rtlCol="0">
+            <a:spAutoFit/>
+          </a:bodyPr>
+          <a:lstStyle/>
+          <a:p>
+            <a:r>
+              <a:rPr lang="en-US">
+                <a:hlinkClick r:id="rId2"/>
+              </a:rPr>
+              <a:t>https://www.youtube.com/watch?v=KnWorqyDSLA</a:t>
+            </a:r>
+            <a:endParaRPr lang="en-US"/>
+          </a:p>
+          <a:p>
+            <a:endParaRPr lang="en-US" dirty="0"/>
+          </a:p>
+        </p:txBody>
+      </p:sp>
+      <p:pic>
+        <p:nvPicPr>
+          <p:cNvPr id="6" name="Picture 5">
+            <a:extLst>
+              <a:ext uri="{FF2B5EF4-FFF2-40B4-BE49-F238E27FC236}">
+                <a16:creationId xmlns:a16="http://schemas.microsoft.com/office/drawing/2014/main" id="{ADAA3EF5-F429-C628-6C89-A06C2F1E1DBA}"/>
+              </a:ext>
+            </a:extLst>
+          </p:cNvPr>
+          <p:cNvPicPr>
+            <a:picLocks noChangeAspect="1"/>
+          </p:cNvPicPr>
+          <p:nvPr/>
+        </p:nvPicPr>
+        <p:blipFill>
+          <a:blip r:embed="rId3">
+            <a:extLst>
+              <a:ext uri="{28A0092B-C50C-407E-A947-70E740481C1C}">
+                <a14:useLocalDpi xmlns:a14="http://schemas.microsoft.com/office/drawing/2010/main" val="0"/>
+              </a:ext>
+            </a:extLst>
+          </a:blip>
+          <a:srcRect/>
+          <a:stretch/>
+        </p:blipFill>
+        <p:spPr>
+          <a:xfrm>
+            <a:off x="947057" y="1088693"/>
+            <a:ext cx="10297885" cy="5315887"/>
+          </a:xfrm>
+          <a:prstGeom prst="rect">
+            <a:avLst/>
+          </a:prstGeom>
+        </p:spPr>
+      </p:pic>
+    </p:spTree>
+    <p:extLst>
+      <p:ext uri="{BB962C8B-B14F-4D97-AF65-F5344CB8AC3E}">
+        <p14:creationId xmlns:p14="http://schemas.microsoft.com/office/powerpoint/2010/main" val="3552284235"/>
+      </p:ext>
+    </p:extLst>
+  </p:cSld>
+  <p:clrMapOvr>
+    <a:masterClrMapping/>
+  </p:clrMapOvr>
+</p:sld>
+</file>
+
+<file path=ppt/slides/slide25.xml><?xml version="1.0" encoding="utf-8"?>
+<p:sld xmlns:a="http://schemas.openxmlformats.org/drawingml/2006/main" xmlns:r="http://schemas.openxmlformats.org/officeDocument/2006/relationships" xmlns:p="http://schemas.openxmlformats.org/presentationml/2006/main">
+  <p:cSld>
+    <p:spTree>
+      <p:nvGrpSpPr>
+        <p:cNvPr id="1" name="">
+          <a:extLst>
+            <a:ext uri="{FF2B5EF4-FFF2-40B4-BE49-F238E27FC236}">
+              <a16:creationId xmlns:a16="http://schemas.microsoft.com/office/drawing/2014/main" id="{A2C00CDF-0A45-C537-5BE6-DAE638D6FEFE}"/>
+            </a:ext>
+          </a:extLst>
+        </p:cNvPr>
+        <p:cNvGrpSpPr/>
+        <p:nvPr/>
+      </p:nvGrpSpPr>
+      <p:grpSpPr>
+        <a:xfrm>
+          <a:off x="0" y="0"/>
+          <a:ext cx="0" cy="0"/>
+          <a:chOff x="0" y="0"/>
+          <a:chExt cx="0" cy="0"/>
+        </a:xfrm>
+      </p:grpSpPr>
+      <p:sp>
+        <p:nvSpPr>
+          <p:cNvPr id="4" name="TextBox 3">
+            <a:extLst>
+              <a:ext uri="{FF2B5EF4-FFF2-40B4-BE49-F238E27FC236}">
+                <a16:creationId xmlns:a16="http://schemas.microsoft.com/office/drawing/2014/main" id="{D7BA59CB-A3B4-B407-9B24-D0CA1B102623}"/>
+              </a:ext>
+            </a:extLst>
+          </p:cNvPr>
+          <p:cNvSpPr txBox="1"/>
+          <p:nvPr/>
+        </p:nvSpPr>
+        <p:spPr>
+          <a:xfrm>
+            <a:off x="1175657" y="435429"/>
+            <a:ext cx="5233292" cy="646331"/>
+          </a:xfrm>
+          <a:prstGeom prst="rect">
+            <a:avLst/>
+          </a:prstGeom>
+          <a:noFill/>
+        </p:spPr>
+        <p:txBody>
+          <a:bodyPr wrap="none" rtlCol="0">
+            <a:spAutoFit/>
+          </a:bodyPr>
+          <a:lstStyle/>
+          <a:p>
+            <a:r>
+              <a:rPr lang="en-US">
+                <a:hlinkClick r:id="rId2"/>
+              </a:rPr>
+              <a:t>https://www.youtube.com/watch?v=KnWorqyDSLA</a:t>
+            </a:r>
+            <a:endParaRPr lang="en-US"/>
+          </a:p>
+          <a:p>
+            <a:endParaRPr lang="en-US" dirty="0"/>
+          </a:p>
+        </p:txBody>
+      </p:sp>
+      <p:pic>
+        <p:nvPicPr>
+          <p:cNvPr id="6" name="Picture 5">
+            <a:extLst>
+              <a:ext uri="{FF2B5EF4-FFF2-40B4-BE49-F238E27FC236}">
+                <a16:creationId xmlns:a16="http://schemas.microsoft.com/office/drawing/2014/main" id="{4223C952-804A-525D-64CE-90109F0A0A0D}"/>
+              </a:ext>
+            </a:extLst>
+          </p:cNvPr>
+          <p:cNvPicPr>
+            <a:picLocks noChangeAspect="1"/>
+          </p:cNvPicPr>
+          <p:nvPr/>
+        </p:nvPicPr>
+        <p:blipFill>
+          <a:blip r:embed="rId3">
+            <a:extLst>
+              <a:ext uri="{28A0092B-C50C-407E-A947-70E740481C1C}">
+                <a14:useLocalDpi xmlns:a14="http://schemas.microsoft.com/office/drawing/2010/main" val="0"/>
+              </a:ext>
+            </a:extLst>
+          </a:blip>
+          <a:srcRect/>
+          <a:stretch/>
+        </p:blipFill>
+        <p:spPr>
+          <a:xfrm>
+            <a:off x="892629" y="1088693"/>
+            <a:ext cx="10225370" cy="5411879"/>
+          </a:xfrm>
+          <a:prstGeom prst="rect">
+            <a:avLst/>
+          </a:prstGeom>
+        </p:spPr>
+      </p:pic>
+    </p:spTree>
+    <p:extLst>
+      <p:ext uri="{BB962C8B-B14F-4D97-AF65-F5344CB8AC3E}">
+        <p14:creationId xmlns:p14="http://schemas.microsoft.com/office/powerpoint/2010/main" val="151067481"/>
+      </p:ext>
+    </p:extLst>
+  </p:cSld>
+  <p:clrMapOvr>
+    <a:masterClrMapping/>
+  </p:clrMapOvr>
+</p:sld>
+</file>
+
+<file path=ppt/slides/slide26.xml><?xml version="1.0" encoding="utf-8"?>
+<p:sld xmlns:a="http://schemas.openxmlformats.org/drawingml/2006/main" xmlns:r="http://schemas.openxmlformats.org/officeDocument/2006/relationships" xmlns:p="http://schemas.openxmlformats.org/presentationml/2006/main">
+  <p:cSld>
+    <p:spTree>
+      <p:nvGrpSpPr>
+        <p:cNvPr id="1" name="">
+          <a:extLst>
+            <a:ext uri="{FF2B5EF4-FFF2-40B4-BE49-F238E27FC236}">
+              <a16:creationId xmlns:a16="http://schemas.microsoft.com/office/drawing/2014/main" id="{4BD7DDAA-00BE-00B4-226D-8202D2CB123E}"/>
+            </a:ext>
+          </a:extLst>
+        </p:cNvPr>
+        <p:cNvGrpSpPr/>
+        <p:nvPr/>
+      </p:nvGrpSpPr>
+      <p:grpSpPr>
+        <a:xfrm>
+          <a:off x="0" y="0"/>
+          <a:ext cx="0" cy="0"/>
+          <a:chOff x="0" y="0"/>
+          <a:chExt cx="0" cy="0"/>
+        </a:xfrm>
+      </p:grpSpPr>
+      <p:sp>
+        <p:nvSpPr>
+          <p:cNvPr id="4" name="TextBox 3">
+            <a:extLst>
+              <a:ext uri="{FF2B5EF4-FFF2-40B4-BE49-F238E27FC236}">
+                <a16:creationId xmlns:a16="http://schemas.microsoft.com/office/drawing/2014/main" id="{3A5E31D1-788F-9665-25B9-3F12E2FB8502}"/>
+              </a:ext>
+            </a:extLst>
+          </p:cNvPr>
+          <p:cNvSpPr txBox="1"/>
+          <p:nvPr/>
+        </p:nvSpPr>
+        <p:spPr>
+          <a:xfrm>
+            <a:off x="1175657" y="435429"/>
+            <a:ext cx="5233292" cy="646331"/>
+          </a:xfrm>
+          <a:prstGeom prst="rect">
+            <a:avLst/>
+          </a:prstGeom>
+          <a:noFill/>
+        </p:spPr>
+        <p:txBody>
+          <a:bodyPr wrap="none" rtlCol="0">
+            <a:spAutoFit/>
+          </a:bodyPr>
+          <a:lstStyle/>
+          <a:p>
+            <a:r>
+              <a:rPr lang="en-US">
+                <a:hlinkClick r:id="rId2"/>
+              </a:rPr>
+              <a:t>https://www.youtube.com/watch?v=KnWorqyDSLA</a:t>
+            </a:r>
+            <a:endParaRPr lang="en-US"/>
+          </a:p>
+          <a:p>
+            <a:endParaRPr lang="en-US" dirty="0"/>
+          </a:p>
+        </p:txBody>
+      </p:sp>
+      <p:pic>
+        <p:nvPicPr>
+          <p:cNvPr id="6" name="Picture 5">
+            <a:extLst>
+              <a:ext uri="{FF2B5EF4-FFF2-40B4-BE49-F238E27FC236}">
+                <a16:creationId xmlns:a16="http://schemas.microsoft.com/office/drawing/2014/main" id="{7AEB6418-5F70-D190-D3C1-8B5628E3C1C2}"/>
+              </a:ext>
+            </a:extLst>
+          </p:cNvPr>
+          <p:cNvPicPr>
+            <a:picLocks noChangeAspect="1"/>
+          </p:cNvPicPr>
+          <p:nvPr/>
+        </p:nvPicPr>
+        <p:blipFill>
+          <a:blip r:embed="rId3">
+            <a:extLst>
+              <a:ext uri="{28A0092B-C50C-407E-A947-70E740481C1C}">
+                <a14:useLocalDpi xmlns:a14="http://schemas.microsoft.com/office/drawing/2010/main" val="0"/>
+              </a:ext>
+            </a:extLst>
+          </a:blip>
+          <a:srcRect/>
+          <a:stretch/>
+        </p:blipFill>
+        <p:spPr>
+          <a:xfrm>
+            <a:off x="936692" y="1088693"/>
+            <a:ext cx="10137243" cy="5411879"/>
+          </a:xfrm>
+          <a:prstGeom prst="rect">
+            <a:avLst/>
+          </a:prstGeom>
+        </p:spPr>
+      </p:pic>
+    </p:spTree>
+    <p:extLst>
+      <p:ext uri="{BB962C8B-B14F-4D97-AF65-F5344CB8AC3E}">
+        <p14:creationId xmlns:p14="http://schemas.microsoft.com/office/powerpoint/2010/main" val="3955799491"/>
+      </p:ext>
+    </p:extLst>
+  </p:cSld>
+  <p:clrMapOvr>
+    <a:masterClrMapping/>
+  </p:clrMapOvr>
+</p:sld>
+</file>
+
+<file path=ppt/slides/slide27.xml><?xml version="1.0" encoding="utf-8"?>
+<p:sld xmlns:a="http://schemas.openxmlformats.org/drawingml/2006/main" xmlns:r="http://schemas.openxmlformats.org/officeDocument/2006/relationships" xmlns:p="http://schemas.openxmlformats.org/presentationml/2006/main">
+  <p:cSld>
+    <p:spTree>
+      <p:nvGrpSpPr>
+        <p:cNvPr id="1" name="">
+          <a:extLst>
+            <a:ext uri="{FF2B5EF4-FFF2-40B4-BE49-F238E27FC236}">
+              <a16:creationId xmlns:a16="http://schemas.microsoft.com/office/drawing/2014/main" id="{983EE4D9-59A0-CD3B-165E-B2FEE3C830E4}"/>
+            </a:ext>
+          </a:extLst>
+        </p:cNvPr>
+        <p:cNvGrpSpPr/>
+        <p:nvPr/>
+      </p:nvGrpSpPr>
+      <p:grpSpPr>
+        <a:xfrm>
+          <a:off x="0" y="0"/>
+          <a:ext cx="0" cy="0"/>
+          <a:chOff x="0" y="0"/>
+          <a:chExt cx="0" cy="0"/>
+        </a:xfrm>
+      </p:grpSpPr>
+      <p:sp>
+        <p:nvSpPr>
+          <p:cNvPr id="4" name="TextBox 3">
+            <a:extLst>
+              <a:ext uri="{FF2B5EF4-FFF2-40B4-BE49-F238E27FC236}">
+                <a16:creationId xmlns:a16="http://schemas.microsoft.com/office/drawing/2014/main" id="{5EED23E1-3514-8744-6C0B-C97619C3C68E}"/>
+              </a:ext>
+            </a:extLst>
+          </p:cNvPr>
+          <p:cNvSpPr txBox="1"/>
+          <p:nvPr/>
+        </p:nvSpPr>
+        <p:spPr>
+          <a:xfrm>
+            <a:off x="1175657" y="435429"/>
+            <a:ext cx="5233292" cy="646331"/>
+          </a:xfrm>
+          <a:prstGeom prst="rect">
+            <a:avLst/>
+          </a:prstGeom>
+          <a:noFill/>
+        </p:spPr>
+        <p:txBody>
+          <a:bodyPr wrap="none" rtlCol="0">
+            <a:spAutoFit/>
+          </a:bodyPr>
+          <a:lstStyle/>
+          <a:p>
+            <a:r>
+              <a:rPr lang="en-US">
+                <a:hlinkClick r:id="rId2"/>
+              </a:rPr>
+              <a:t>https://www.youtube.com/watch?v=KnWorqyDSLA</a:t>
+            </a:r>
+            <a:endParaRPr lang="en-US"/>
+          </a:p>
+          <a:p>
+            <a:endParaRPr lang="en-US" dirty="0"/>
+          </a:p>
+        </p:txBody>
+      </p:sp>
+      <p:pic>
+        <p:nvPicPr>
+          <p:cNvPr id="6" name="Picture 5">
+            <a:extLst>
+              <a:ext uri="{FF2B5EF4-FFF2-40B4-BE49-F238E27FC236}">
+                <a16:creationId xmlns:a16="http://schemas.microsoft.com/office/drawing/2014/main" id="{66229A06-F49C-4184-CD0F-F21629E62798}"/>
+              </a:ext>
+            </a:extLst>
+          </p:cNvPr>
+          <p:cNvPicPr>
+            <a:picLocks noChangeAspect="1"/>
+          </p:cNvPicPr>
+          <p:nvPr/>
+        </p:nvPicPr>
+        <p:blipFill>
+          <a:blip r:embed="rId3">
+            <a:extLst>
+              <a:ext uri="{28A0092B-C50C-407E-A947-70E740481C1C}">
+                <a14:useLocalDpi xmlns:a14="http://schemas.microsoft.com/office/drawing/2010/main" val="0"/>
+              </a:ext>
+            </a:extLst>
+          </a:blip>
+          <a:srcRect/>
+          <a:stretch/>
+        </p:blipFill>
+        <p:spPr>
+          <a:xfrm>
+            <a:off x="187548" y="1382486"/>
+            <a:ext cx="11816904" cy="4586083"/>
+          </a:xfrm>
+          <a:prstGeom prst="rect">
+            <a:avLst/>
+          </a:prstGeom>
+        </p:spPr>
+      </p:pic>
+      <p:sp>
+        <p:nvSpPr>
+          <p:cNvPr id="2" name="Rectangle 1">
+            <a:extLst>
+              <a:ext uri="{FF2B5EF4-FFF2-40B4-BE49-F238E27FC236}">
+                <a16:creationId xmlns:a16="http://schemas.microsoft.com/office/drawing/2014/main" id="{10345B35-DC6E-6493-7FBA-0125058832DD}"/>
+              </a:ext>
+            </a:extLst>
+          </p:cNvPr>
+          <p:cNvSpPr/>
+          <p:nvPr/>
+        </p:nvSpPr>
+        <p:spPr>
+          <a:xfrm>
+            <a:off x="187548" y="3193324"/>
+            <a:ext cx="12275820" cy="3973286"/>
+          </a:xfrm>
+          <a:prstGeom prst="rect">
+            <a:avLst/>
+          </a:prstGeom>
+          <a:solidFill>
+            <a:schemeClr val="bg1"/>
+          </a:solidFill>
+          <a:ln>
+            <a:noFill/>
+          </a:ln>
+        </p:spPr>
+        <p:style>
+          <a:lnRef idx="2">
+            <a:schemeClr val="accent1">
+              <a:shade val="15000"/>
+            </a:schemeClr>
+          </a:lnRef>
+          <a:fillRef idx="1">
+            <a:schemeClr val="accent1"/>
+          </a:fillRef>
+          <a:effectRef idx="0">
+            <a:schemeClr val="accent1"/>
+          </a:effectRef>
+          <a:fontRef idx="minor">
+            <a:schemeClr val="lt1"/>
+          </a:fontRef>
+        </p:style>
+        <p:txBody>
+          <a:bodyPr rtlCol="0" anchor="ctr"/>
+          <a:lstStyle/>
+          <a:p>
+            <a:pPr algn="ctr"/>
+            <a:endParaRPr lang="en-US"/>
+          </a:p>
+        </p:txBody>
+      </p:sp>
+    </p:spTree>
+    <p:extLst>
+      <p:ext uri="{BB962C8B-B14F-4D97-AF65-F5344CB8AC3E}">
+        <p14:creationId xmlns:p14="http://schemas.microsoft.com/office/powerpoint/2010/main" val="3471532562"/>
+      </p:ext>
+    </p:extLst>
+  </p:cSld>
+  <p:clrMapOvr>
+    <a:masterClrMapping/>
+  </p:clrMapOvr>
+</p:sld>
+</file>
+
+<file path=ppt/slides/slide28.xml><?xml version="1.0" encoding="utf-8"?>
+<p:sld xmlns:a="http://schemas.openxmlformats.org/drawingml/2006/main" xmlns:r="http://schemas.openxmlformats.org/officeDocument/2006/relationships" xmlns:p="http://schemas.openxmlformats.org/presentationml/2006/main">
+  <p:cSld>
+    <p:spTree>
+      <p:nvGrpSpPr>
+        <p:cNvPr id="1" name="">
+          <a:extLst>
+            <a:ext uri="{FF2B5EF4-FFF2-40B4-BE49-F238E27FC236}">
+              <a16:creationId xmlns:a16="http://schemas.microsoft.com/office/drawing/2014/main" id="{D0D915F8-1205-A6E0-8749-EF2D511D1DD8}"/>
+            </a:ext>
+          </a:extLst>
+        </p:cNvPr>
+        <p:cNvGrpSpPr/>
+        <p:nvPr/>
+      </p:nvGrpSpPr>
+      <p:grpSpPr>
+        <a:xfrm>
+          <a:off x="0" y="0"/>
+          <a:ext cx="0" cy="0"/>
+          <a:chOff x="0" y="0"/>
+          <a:chExt cx="0" cy="0"/>
+        </a:xfrm>
+      </p:grpSpPr>
+      <p:sp>
+        <p:nvSpPr>
+          <p:cNvPr id="4" name="TextBox 3">
+            <a:extLst>
+              <a:ext uri="{FF2B5EF4-FFF2-40B4-BE49-F238E27FC236}">
+                <a16:creationId xmlns:a16="http://schemas.microsoft.com/office/drawing/2014/main" id="{515C320E-A27C-3A2B-D4D2-3BFD5CFD8F32}"/>
+              </a:ext>
+            </a:extLst>
+          </p:cNvPr>
+          <p:cNvSpPr txBox="1"/>
+          <p:nvPr/>
+        </p:nvSpPr>
+        <p:spPr>
+          <a:xfrm>
+            <a:off x="1175657" y="435429"/>
+            <a:ext cx="5233292" cy="646331"/>
+          </a:xfrm>
+          <a:prstGeom prst="rect">
+            <a:avLst/>
+          </a:prstGeom>
+          <a:noFill/>
+        </p:spPr>
+        <p:txBody>
+          <a:bodyPr wrap="none" rtlCol="0">
+            <a:spAutoFit/>
+          </a:bodyPr>
+          <a:lstStyle/>
+          <a:p>
+            <a:r>
+              <a:rPr lang="en-US">
+                <a:hlinkClick r:id="rId2"/>
+              </a:rPr>
+              <a:t>https://www.youtube.com/watch?v=KnWorqyDSLA</a:t>
+            </a:r>
+            <a:endParaRPr lang="en-US"/>
+          </a:p>
+          <a:p>
+            <a:endParaRPr lang="en-US" dirty="0"/>
+          </a:p>
+        </p:txBody>
+      </p:sp>
+      <p:pic>
+        <p:nvPicPr>
+          <p:cNvPr id="6" name="Picture 5">
+            <a:extLst>
+              <a:ext uri="{FF2B5EF4-FFF2-40B4-BE49-F238E27FC236}">
+                <a16:creationId xmlns:a16="http://schemas.microsoft.com/office/drawing/2014/main" id="{9F2581E1-4ED5-1465-7771-A161FB3F46C3}"/>
+              </a:ext>
+            </a:extLst>
+          </p:cNvPr>
+          <p:cNvPicPr>
+            <a:picLocks noChangeAspect="1"/>
+          </p:cNvPicPr>
+          <p:nvPr/>
+        </p:nvPicPr>
+        <p:blipFill>
+          <a:blip r:embed="rId3">
+            <a:extLst>
+              <a:ext uri="{28A0092B-C50C-407E-A947-70E740481C1C}">
+                <a14:useLocalDpi xmlns:a14="http://schemas.microsoft.com/office/drawing/2010/main" val="0"/>
+              </a:ext>
+            </a:extLst>
+          </a:blip>
+          <a:srcRect/>
+          <a:stretch/>
+        </p:blipFill>
+        <p:spPr>
+          <a:xfrm>
+            <a:off x="187548" y="1382486"/>
+            <a:ext cx="11816904" cy="4586083"/>
+          </a:xfrm>
+          <a:prstGeom prst="rect">
+            <a:avLst/>
+          </a:prstGeom>
+        </p:spPr>
+      </p:pic>
+      <p:sp>
+        <p:nvSpPr>
+          <p:cNvPr id="2" name="Rectangle 1">
+            <a:extLst>
+              <a:ext uri="{FF2B5EF4-FFF2-40B4-BE49-F238E27FC236}">
+                <a16:creationId xmlns:a16="http://schemas.microsoft.com/office/drawing/2014/main" id="{D5EB0E8A-9D31-1518-DB88-473CD5523027}"/>
+              </a:ext>
+            </a:extLst>
+          </p:cNvPr>
+          <p:cNvSpPr/>
+          <p:nvPr/>
+        </p:nvSpPr>
+        <p:spPr>
+          <a:xfrm>
+            <a:off x="187548" y="4297680"/>
+            <a:ext cx="12275820" cy="2846070"/>
+          </a:xfrm>
+          <a:prstGeom prst="rect">
+            <a:avLst/>
+          </a:prstGeom>
+          <a:solidFill>
+            <a:schemeClr val="bg1"/>
+          </a:solidFill>
+          <a:ln>
+            <a:noFill/>
+          </a:ln>
+        </p:spPr>
+        <p:style>
+          <a:lnRef idx="2">
+            <a:schemeClr val="accent1">
+              <a:shade val="15000"/>
+            </a:schemeClr>
+          </a:lnRef>
+          <a:fillRef idx="1">
+            <a:schemeClr val="accent1"/>
+          </a:fillRef>
+          <a:effectRef idx="0">
+            <a:schemeClr val="accent1"/>
+          </a:effectRef>
+          <a:fontRef idx="minor">
+            <a:schemeClr val="lt1"/>
+          </a:fontRef>
+        </p:style>
+        <p:txBody>
+          <a:bodyPr rtlCol="0" anchor="ctr"/>
+          <a:lstStyle/>
+          <a:p>
+            <a:pPr algn="ctr"/>
+            <a:endParaRPr lang="en-US"/>
+          </a:p>
+        </p:txBody>
+      </p:sp>
+    </p:spTree>
+    <p:extLst>
+      <p:ext uri="{BB962C8B-B14F-4D97-AF65-F5344CB8AC3E}">
+        <p14:creationId xmlns:p14="http://schemas.microsoft.com/office/powerpoint/2010/main" val="696111266"/>
+      </p:ext>
+    </p:extLst>
+  </p:cSld>
+  <p:clrMapOvr>
+    <a:masterClrMapping/>
+  </p:clrMapOvr>
+</p:sld>
+</file>
+
+<file path=ppt/slides/slide29.xml><?xml version="1.0" encoding="utf-8"?>
+<p:sld xmlns:a="http://schemas.openxmlformats.org/drawingml/2006/main" xmlns:r="http://schemas.openxmlformats.org/officeDocument/2006/relationships" xmlns:p="http://schemas.openxmlformats.org/presentationml/2006/main">
+  <p:cSld>
+    <p:spTree>
+      <p:nvGrpSpPr>
+        <p:cNvPr id="1" name="">
+          <a:extLst>
+            <a:ext uri="{FF2B5EF4-FFF2-40B4-BE49-F238E27FC236}">
+              <a16:creationId xmlns:a16="http://schemas.microsoft.com/office/drawing/2014/main" id="{BFEACBFC-434C-1308-060F-F516150836ED}"/>
+            </a:ext>
+          </a:extLst>
+        </p:cNvPr>
+        <p:cNvGrpSpPr/>
+        <p:nvPr/>
+      </p:nvGrpSpPr>
+      <p:grpSpPr>
+        <a:xfrm>
+          <a:off x="0" y="0"/>
+          <a:ext cx="0" cy="0"/>
+          <a:chOff x="0" y="0"/>
+          <a:chExt cx="0" cy="0"/>
+        </a:xfrm>
+      </p:grpSpPr>
+      <p:sp>
+        <p:nvSpPr>
+          <p:cNvPr id="4" name="TextBox 3">
+            <a:extLst>
+              <a:ext uri="{FF2B5EF4-FFF2-40B4-BE49-F238E27FC236}">
+                <a16:creationId xmlns:a16="http://schemas.microsoft.com/office/drawing/2014/main" id="{81E14D45-F78A-425C-E4A7-E64D0ADBFFF4}"/>
+              </a:ext>
+            </a:extLst>
+          </p:cNvPr>
+          <p:cNvSpPr txBox="1"/>
+          <p:nvPr/>
+        </p:nvSpPr>
+        <p:spPr>
+          <a:xfrm>
+            <a:off x="1175657" y="435429"/>
+            <a:ext cx="5233292" cy="646331"/>
+          </a:xfrm>
+          <a:prstGeom prst="rect">
+            <a:avLst/>
+          </a:prstGeom>
+          <a:noFill/>
+        </p:spPr>
+        <p:txBody>
+          <a:bodyPr wrap="none" rtlCol="0">
+            <a:spAutoFit/>
+          </a:bodyPr>
+          <a:lstStyle/>
+          <a:p>
+            <a:r>
+              <a:rPr lang="en-US">
+                <a:hlinkClick r:id="rId2"/>
+              </a:rPr>
+              <a:t>https://www.youtube.com/watch?v=KnWorqyDSLA</a:t>
+            </a:r>
+            <a:endParaRPr lang="en-US"/>
+          </a:p>
+          <a:p>
+            <a:endParaRPr lang="en-US" dirty="0"/>
+          </a:p>
+        </p:txBody>
+      </p:sp>
+      <p:pic>
+        <p:nvPicPr>
+          <p:cNvPr id="6" name="Picture 5">
+            <a:extLst>
+              <a:ext uri="{FF2B5EF4-FFF2-40B4-BE49-F238E27FC236}">
+                <a16:creationId xmlns:a16="http://schemas.microsoft.com/office/drawing/2014/main" id="{EF993087-BDFA-BF04-C70E-3EF1400CABF5}"/>
+              </a:ext>
+            </a:extLst>
+          </p:cNvPr>
+          <p:cNvPicPr>
+            <a:picLocks noChangeAspect="1"/>
+          </p:cNvPicPr>
+          <p:nvPr/>
+        </p:nvPicPr>
+        <p:blipFill>
+          <a:blip r:embed="rId3">
+            <a:extLst>
+              <a:ext uri="{28A0092B-C50C-407E-A947-70E740481C1C}">
+                <a14:useLocalDpi xmlns:a14="http://schemas.microsoft.com/office/drawing/2010/main" val="0"/>
+              </a:ext>
+            </a:extLst>
+          </a:blip>
+          <a:srcRect/>
+          <a:stretch/>
+        </p:blipFill>
+        <p:spPr>
+          <a:xfrm>
+            <a:off x="187548" y="1382486"/>
+            <a:ext cx="11816904" cy="4586083"/>
+          </a:xfrm>
+          <a:prstGeom prst="rect">
+            <a:avLst/>
+          </a:prstGeom>
+        </p:spPr>
+      </p:pic>
+      <p:sp>
+        <p:nvSpPr>
+          <p:cNvPr id="2" name="Rectangle 1">
+            <a:extLst>
+              <a:ext uri="{FF2B5EF4-FFF2-40B4-BE49-F238E27FC236}">
+                <a16:creationId xmlns:a16="http://schemas.microsoft.com/office/drawing/2014/main" id="{C82A9D52-CFFA-EEEC-3676-8AAD6ECC5013}"/>
+              </a:ext>
+            </a:extLst>
+          </p:cNvPr>
+          <p:cNvSpPr/>
+          <p:nvPr/>
+        </p:nvSpPr>
+        <p:spPr>
+          <a:xfrm>
+            <a:off x="187548" y="5223510"/>
+            <a:ext cx="12275820" cy="1920240"/>
+          </a:xfrm>
+          <a:prstGeom prst="rect">
+            <a:avLst/>
+          </a:prstGeom>
+          <a:solidFill>
+            <a:schemeClr val="bg1"/>
+          </a:solidFill>
+          <a:ln>
+            <a:noFill/>
+          </a:ln>
+        </p:spPr>
+        <p:style>
+          <a:lnRef idx="2">
+            <a:schemeClr val="accent1">
+              <a:shade val="15000"/>
+            </a:schemeClr>
+          </a:lnRef>
+          <a:fillRef idx="1">
+            <a:schemeClr val="accent1"/>
+          </a:fillRef>
+          <a:effectRef idx="0">
+            <a:schemeClr val="accent1"/>
+          </a:effectRef>
+          <a:fontRef idx="minor">
+            <a:schemeClr val="lt1"/>
+          </a:fontRef>
+        </p:style>
+        <p:txBody>
+          <a:bodyPr rtlCol="0" anchor="ctr"/>
+          <a:lstStyle/>
+          <a:p>
+            <a:pPr algn="ctr"/>
+            <a:endParaRPr lang="en-US"/>
+          </a:p>
+        </p:txBody>
+      </p:sp>
+    </p:spTree>
+    <p:extLst>
+      <p:ext uri="{BB962C8B-B14F-4D97-AF65-F5344CB8AC3E}">
+        <p14:creationId xmlns:p14="http://schemas.microsoft.com/office/powerpoint/2010/main" val="3437785258"/>
+      </p:ext>
+    </p:extLst>
+  </p:cSld>
+  <p:clrMapOvr>
+    <a:masterClrMapping/>
+  </p:clrMapOvr>
+</p:sld>
+</file>
+
 <file path=ppt/slides/slide3.xml><?xml version="1.0" encoding="utf-8"?>
 <p:sld xmlns:a="http://schemas.openxmlformats.org/drawingml/2006/main" xmlns:r="http://schemas.openxmlformats.org/officeDocument/2006/relationships" xmlns:p="http://schemas.openxmlformats.org/presentationml/2006/main">
   <p:cSld>
@@ -9346,6 +11676,499 @@
     <p:extLst>
       <p:ext uri="{BB962C8B-B14F-4D97-AF65-F5344CB8AC3E}">
         <p14:creationId xmlns:p14="http://schemas.microsoft.com/office/powerpoint/2010/main" val="2833549802"/>
+      </p:ext>
+    </p:extLst>
+  </p:cSld>
+  <p:clrMapOvr>
+    <a:masterClrMapping/>
+  </p:clrMapOvr>
+</p:sld>
+</file>
+
+<file path=ppt/slides/slide30.xml><?xml version="1.0" encoding="utf-8"?>
+<p:sld xmlns:a="http://schemas.openxmlformats.org/drawingml/2006/main" xmlns:r="http://schemas.openxmlformats.org/officeDocument/2006/relationships" xmlns:p="http://schemas.openxmlformats.org/presentationml/2006/main">
+  <p:cSld>
+    <p:spTree>
+      <p:nvGrpSpPr>
+        <p:cNvPr id="1" name="">
+          <a:extLst>
+            <a:ext uri="{FF2B5EF4-FFF2-40B4-BE49-F238E27FC236}">
+              <a16:creationId xmlns:a16="http://schemas.microsoft.com/office/drawing/2014/main" id="{53A50F9E-EC33-160B-74B0-7DFFDE9BD9CD}"/>
+            </a:ext>
+          </a:extLst>
+        </p:cNvPr>
+        <p:cNvGrpSpPr/>
+        <p:nvPr/>
+      </p:nvGrpSpPr>
+      <p:grpSpPr>
+        <a:xfrm>
+          <a:off x="0" y="0"/>
+          <a:ext cx="0" cy="0"/>
+          <a:chOff x="0" y="0"/>
+          <a:chExt cx="0" cy="0"/>
+        </a:xfrm>
+      </p:grpSpPr>
+      <p:sp>
+        <p:nvSpPr>
+          <p:cNvPr id="4" name="TextBox 3">
+            <a:extLst>
+              <a:ext uri="{FF2B5EF4-FFF2-40B4-BE49-F238E27FC236}">
+                <a16:creationId xmlns:a16="http://schemas.microsoft.com/office/drawing/2014/main" id="{413C72E8-72DB-CF67-AFEB-7F021081EF53}"/>
+              </a:ext>
+            </a:extLst>
+          </p:cNvPr>
+          <p:cNvSpPr txBox="1"/>
+          <p:nvPr/>
+        </p:nvSpPr>
+        <p:spPr>
+          <a:xfrm>
+            <a:off x="1175657" y="435429"/>
+            <a:ext cx="5233292" cy="646331"/>
+          </a:xfrm>
+          <a:prstGeom prst="rect">
+            <a:avLst/>
+          </a:prstGeom>
+          <a:noFill/>
+        </p:spPr>
+        <p:txBody>
+          <a:bodyPr wrap="none" rtlCol="0">
+            <a:spAutoFit/>
+          </a:bodyPr>
+          <a:lstStyle/>
+          <a:p>
+            <a:r>
+              <a:rPr lang="en-US">
+                <a:hlinkClick r:id="rId2"/>
+              </a:rPr>
+              <a:t>https://www.youtube.com/watch?v=KnWorqyDSLA</a:t>
+            </a:r>
+            <a:endParaRPr lang="en-US"/>
+          </a:p>
+          <a:p>
+            <a:endParaRPr lang="en-US" dirty="0"/>
+          </a:p>
+        </p:txBody>
+      </p:sp>
+      <p:pic>
+        <p:nvPicPr>
+          <p:cNvPr id="6" name="Picture 5">
+            <a:extLst>
+              <a:ext uri="{FF2B5EF4-FFF2-40B4-BE49-F238E27FC236}">
+                <a16:creationId xmlns:a16="http://schemas.microsoft.com/office/drawing/2014/main" id="{D13CE42E-5933-921A-5BC4-609038F5A490}"/>
+              </a:ext>
+            </a:extLst>
+          </p:cNvPr>
+          <p:cNvPicPr>
+            <a:picLocks noChangeAspect="1"/>
+          </p:cNvPicPr>
+          <p:nvPr/>
+        </p:nvPicPr>
+        <p:blipFill>
+          <a:blip r:embed="rId3">
+            <a:extLst>
+              <a:ext uri="{28A0092B-C50C-407E-A947-70E740481C1C}">
+                <a14:useLocalDpi xmlns:a14="http://schemas.microsoft.com/office/drawing/2010/main" val="0"/>
+              </a:ext>
+            </a:extLst>
+          </a:blip>
+          <a:srcRect/>
+          <a:stretch/>
+        </p:blipFill>
+        <p:spPr>
+          <a:xfrm>
+            <a:off x="187548" y="1382486"/>
+            <a:ext cx="11816904" cy="4586083"/>
+          </a:xfrm>
+          <a:prstGeom prst="rect">
+            <a:avLst/>
+          </a:prstGeom>
+        </p:spPr>
+      </p:pic>
+    </p:spTree>
+    <p:extLst>
+      <p:ext uri="{BB962C8B-B14F-4D97-AF65-F5344CB8AC3E}">
+        <p14:creationId xmlns:p14="http://schemas.microsoft.com/office/powerpoint/2010/main" val="1640185660"/>
+      </p:ext>
+    </p:extLst>
+  </p:cSld>
+  <p:clrMapOvr>
+    <a:masterClrMapping/>
+  </p:clrMapOvr>
+</p:sld>
+</file>
+
+<file path=ppt/slides/slide31.xml><?xml version="1.0" encoding="utf-8"?>
+<p:sld xmlns:a="http://schemas.openxmlformats.org/drawingml/2006/main" xmlns:r="http://schemas.openxmlformats.org/officeDocument/2006/relationships" xmlns:p="http://schemas.openxmlformats.org/presentationml/2006/main">
+  <p:cSld>
+    <p:bg>
+      <p:bgPr>
+        <a:solidFill>
+          <a:schemeClr val="bg1"/>
+        </a:solidFill>
+        <a:effectLst/>
+      </p:bgPr>
+    </p:bg>
+    <p:spTree>
+      <p:nvGrpSpPr>
+        <p:cNvPr id="1" name=""/>
+        <p:cNvGrpSpPr/>
+        <p:nvPr/>
+      </p:nvGrpSpPr>
+      <p:grpSpPr>
+        <a:xfrm>
+          <a:off x="0" y="0"/>
+          <a:ext cx="0" cy="0"/>
+          <a:chOff x="0" y="0"/>
+          <a:chExt cx="0" cy="0"/>
+        </a:xfrm>
+      </p:grpSpPr>
+      <p:sp useBgFill="1">
+        <p:nvSpPr>
+          <p:cNvPr id="7" name="Rectangle 6">
+            <a:extLst>
+              <a:ext uri="{FF2B5EF4-FFF2-40B4-BE49-F238E27FC236}">
+                <a16:creationId xmlns:a16="http://schemas.microsoft.com/office/drawing/2014/main" id="{BAD76F3E-3A97-486B-B402-44400A8B9173}"/>
+              </a:ext>
+              <a:ext uri="{C183D7F6-B498-43B3-948B-1728B52AA6E4}">
+                <adec:decorative xmlns:adec="http://schemas.microsoft.com/office/drawing/2017/decorative" val="1"/>
+              </a:ext>
+            </a:extLst>
+          </p:cNvPr>
+          <p:cNvSpPr>
+            <a:spLocks noGrp="1" noRot="1" noChangeAspect="1" noMove="1" noResize="1" noEditPoints="1" noAdjustHandles="1" noChangeArrowheads="1" noChangeShapeType="1" noTextEdit="1"/>
+          </p:cNvSpPr>
+          <p:nvPr>
+            <p:extLst>
+              <p:ext uri="{386F3935-93C4-4BCD-93E2-E3B085C9AB24}">
+                <p16:designElem xmlns:p16="http://schemas.microsoft.com/office/powerpoint/2015/main" val="1"/>
+              </p:ext>
+            </p:extLst>
+          </p:nvPr>
+        </p:nvSpPr>
+        <p:spPr>
+          <a:xfrm>
+            <a:off x="0" y="0"/>
+            <a:ext cx="12192000" cy="6858000"/>
+          </a:xfrm>
+          <a:prstGeom prst="rect">
+            <a:avLst/>
+          </a:prstGeom>
+          <a:ln>
+            <a:noFill/>
+          </a:ln>
+        </p:spPr>
+        <p:style>
+          <a:lnRef idx="2">
+            <a:schemeClr val="accent1">
+              <a:shade val="50000"/>
+            </a:schemeClr>
+          </a:lnRef>
+          <a:fillRef idx="1">
+            <a:schemeClr val="accent1"/>
+          </a:fillRef>
+          <a:effectRef idx="0">
+            <a:schemeClr val="accent1"/>
+          </a:effectRef>
+          <a:fontRef idx="minor">
+            <a:schemeClr val="lt1"/>
+          </a:fontRef>
+        </p:style>
+        <p:txBody>
+          <a:bodyPr rtlCol="0" anchor="ctr"/>
+          <a:lstStyle/>
+          <a:p>
+            <a:pPr algn="ctr"/>
+            <a:endParaRPr lang="en-US"/>
+          </a:p>
+        </p:txBody>
+      </p:sp>
+      <p:sp>
+        <p:nvSpPr>
+          <p:cNvPr id="2" name="Title 1">
+            <a:extLst>
+              <a:ext uri="{FF2B5EF4-FFF2-40B4-BE49-F238E27FC236}">
+                <a16:creationId xmlns:a16="http://schemas.microsoft.com/office/drawing/2014/main" id="{0F89E9F8-2A3C-8195-F6DB-A0CF74A0B2F8}"/>
+              </a:ext>
+            </a:extLst>
+          </p:cNvPr>
+          <p:cNvSpPr>
+            <a:spLocks noGrp="1" noRot="1" noMove="1" noResize="1" noEditPoints="1" noAdjustHandles="1" noChangeArrowheads="1" noChangeShapeType="1"/>
+          </p:cNvSpPr>
+          <p:nvPr>
+            <p:ph type="title"/>
+          </p:nvPr>
+        </p:nvSpPr>
+        <p:spPr>
+          <a:xfrm>
+            <a:off x="838199" y="1093788"/>
+            <a:ext cx="10506455" cy="2967208"/>
+          </a:xfrm>
+        </p:spPr>
+        <p:txBody>
+          <a:bodyPr vert="horz" lIns="91440" tIns="45720" rIns="91440" bIns="45720" rtlCol="0" anchor="b">
+            <a:normAutofit/>
+          </a:bodyPr>
+          <a:lstStyle/>
+          <a:p>
+            <a:r>
+              <a:rPr lang="en-US" sz="8000" kern="1200">
+                <a:solidFill>
+                  <a:schemeClr val="tx1"/>
+                </a:solidFill>
+                <a:latin typeface="+mj-lt"/>
+                <a:ea typeface="+mj-ea"/>
+                <a:cs typeface="+mj-cs"/>
+              </a:rPr>
+              <a:t>Longest Common Subsequence</a:t>
+            </a:r>
+          </a:p>
+        </p:txBody>
+      </p:sp>
+      <p:sp>
+        <p:nvSpPr>
+          <p:cNvPr id="9" name="Rectangle 8">
+            <a:extLst>
+              <a:ext uri="{FF2B5EF4-FFF2-40B4-BE49-F238E27FC236}">
+                <a16:creationId xmlns:a16="http://schemas.microsoft.com/office/drawing/2014/main" id="{391F6B52-91F4-4AEB-B6DB-29FEBCF28C8B}"/>
+              </a:ext>
+              <a:ext uri="{C183D7F6-B498-43B3-948B-1728B52AA6E4}">
+                <adec:decorative xmlns:adec="http://schemas.microsoft.com/office/drawing/2017/decorative" val="1"/>
+              </a:ext>
+            </a:extLst>
+          </p:cNvPr>
+          <p:cNvSpPr>
+            <a:spLocks noGrp="1" noRot="1" noChangeAspect="1" noMove="1" noResize="1" noEditPoints="1" noAdjustHandles="1" noChangeArrowheads="1" noChangeShapeType="1" noTextEdit="1"/>
+          </p:cNvSpPr>
+          <p:nvPr>
+            <p:extLst>
+              <p:ext uri="{386F3935-93C4-4BCD-93E2-E3B085C9AB24}">
+                <p16:designElem xmlns:p16="http://schemas.microsoft.com/office/powerpoint/2015/main" val="1"/>
+              </p:ext>
+            </p:extLst>
+          </p:nvPr>
+        </p:nvSpPr>
+        <p:spPr>
+          <a:xfrm>
+            <a:off x="841248" y="4331166"/>
+            <a:ext cx="10506456" cy="18288"/>
+          </a:xfrm>
+          <a:prstGeom prst="rect">
+            <a:avLst/>
+          </a:prstGeom>
+          <a:solidFill>
+            <a:srgbClr val="D5D5D5"/>
+          </a:solidFill>
+          <a:ln w="3175">
+            <a:noFill/>
+          </a:ln>
+          <a:effectLst/>
+        </p:spPr>
+        <p:style>
+          <a:lnRef idx="2">
+            <a:schemeClr val="accent1">
+              <a:shade val="50000"/>
+            </a:schemeClr>
+          </a:lnRef>
+          <a:fillRef idx="1">
+            <a:schemeClr val="accent1"/>
+          </a:fillRef>
+          <a:effectRef idx="0">
+            <a:schemeClr val="accent1"/>
+          </a:effectRef>
+          <a:fontRef idx="minor">
+            <a:schemeClr val="lt1"/>
+          </a:fontRef>
+        </p:style>
+        <p:txBody>
+          <a:bodyPr rtlCol="0" anchor="ctr"/>
+          <a:lstStyle/>
+          <a:p>
+            <a:pPr algn="ctr"/>
+            <a:endParaRPr lang="en-US">
+              <a:solidFill>
+                <a:prstClr val="white"/>
+              </a:solidFill>
+              <a:latin typeface="Calibri" panose="020F0502020204030204"/>
+            </a:endParaRPr>
+          </a:p>
+        </p:txBody>
+      </p:sp>
+      <p:sp>
+        <p:nvSpPr>
+          <p:cNvPr id="11" name="Rectangle 10">
+            <a:extLst>
+              <a:ext uri="{FF2B5EF4-FFF2-40B4-BE49-F238E27FC236}">
+                <a16:creationId xmlns:a16="http://schemas.microsoft.com/office/drawing/2014/main" id="{2CD6F061-7C53-44F4-9794-953DB70A451B}"/>
+              </a:ext>
+              <a:ext uri="{C183D7F6-B498-43B3-948B-1728B52AA6E4}">
+                <adec:decorative xmlns:adec="http://schemas.microsoft.com/office/drawing/2017/decorative" val="1"/>
+              </a:ext>
+            </a:extLst>
+          </p:cNvPr>
+          <p:cNvSpPr>
+            <a:spLocks noGrp="1" noRot="1" noChangeAspect="1" noMove="1" noResize="1" noEditPoints="1" noAdjustHandles="1" noChangeArrowheads="1" noChangeShapeType="1" noTextEdit="1"/>
+          </p:cNvSpPr>
+          <p:nvPr>
+            <p:extLst>
+              <p:ext uri="{386F3935-93C4-4BCD-93E2-E3B085C9AB24}">
+                <p16:designElem xmlns:p16="http://schemas.microsoft.com/office/powerpoint/2015/main" val="1"/>
+              </p:ext>
+            </p:extLst>
+          </p:nvPr>
+        </p:nvSpPr>
+        <p:spPr>
+          <a:xfrm rot="5400000">
+            <a:off x="9346882" y="2348839"/>
+            <a:ext cx="54864" cy="3946779"/>
+          </a:xfrm>
+          <a:prstGeom prst="rect">
+            <a:avLst/>
+          </a:prstGeom>
+          <a:solidFill>
+            <a:schemeClr val="accent2"/>
+          </a:solidFill>
+          <a:ln>
+            <a:noFill/>
+          </a:ln>
+        </p:spPr>
+        <p:style>
+          <a:lnRef idx="2">
+            <a:schemeClr val="accent1">
+              <a:shade val="50000"/>
+            </a:schemeClr>
+          </a:lnRef>
+          <a:fillRef idx="1">
+            <a:schemeClr val="accent1"/>
+          </a:fillRef>
+          <a:effectRef idx="0">
+            <a:schemeClr val="accent1"/>
+          </a:effectRef>
+          <a:fontRef idx="minor">
+            <a:schemeClr val="lt1"/>
+          </a:fontRef>
+        </p:style>
+        <p:txBody>
+          <a:bodyPr rtlCol="0" anchor="ctr"/>
+          <a:lstStyle/>
+          <a:p>
+            <a:pPr marL="0" marR="0" lvl="0" indent="0" algn="ctr" defTabSz="914400" rtl="0" eaLnBrk="1" fontAlgn="auto" latinLnBrk="0" hangingPunct="1">
+              <a:lnSpc>
+                <a:spcPct val="100000"/>
+              </a:lnSpc>
+              <a:spcBef>
+                <a:spcPts val="0"/>
+              </a:spcBef>
+              <a:spcAft>
+                <a:spcPts val="0"/>
+              </a:spcAft>
+              <a:buClrTx/>
+              <a:buSzTx/>
+              <a:buFontTx/>
+              <a:buNone/>
+              <a:tabLst/>
+              <a:defRPr/>
+            </a:pPr>
+            <a:endParaRPr kumimoji="0" lang="en-US" sz="1800" b="0" i="0" u="none" strike="noStrike" kern="1200" cap="none" spc="0" normalizeH="0" baseline="0" noProof="0">
+              <a:ln>
+                <a:noFill/>
+              </a:ln>
+              <a:solidFill>
+                <a:prstClr val="white"/>
+              </a:solidFill>
+              <a:effectLst/>
+              <a:uLnTx/>
+              <a:uFillTx/>
+              <a:latin typeface="Calibri" panose="020F0502020204030204"/>
+              <a:ea typeface="+mn-ea"/>
+              <a:cs typeface="+mn-cs"/>
+            </a:endParaRPr>
+          </a:p>
+        </p:txBody>
+      </p:sp>
+    </p:spTree>
+    <p:extLst>
+      <p:ext uri="{BB962C8B-B14F-4D97-AF65-F5344CB8AC3E}">
+        <p14:creationId xmlns:p14="http://schemas.microsoft.com/office/powerpoint/2010/main" val="3004034251"/>
+      </p:ext>
+    </p:extLst>
+  </p:cSld>
+  <p:clrMapOvr>
+    <a:masterClrMapping/>
+  </p:clrMapOvr>
+</p:sld>
+</file>
+
+<file path=ppt/slides/slide32.xml><?xml version="1.0" encoding="utf-8"?>
+<p:sld xmlns:a="http://schemas.openxmlformats.org/drawingml/2006/main" xmlns:r="http://schemas.openxmlformats.org/officeDocument/2006/relationships" xmlns:p="http://schemas.openxmlformats.org/presentationml/2006/main">
+  <p:cSld>
+    <p:spTree>
+      <p:nvGrpSpPr>
+        <p:cNvPr id="1" name=""/>
+        <p:cNvGrpSpPr/>
+        <p:nvPr/>
+      </p:nvGrpSpPr>
+      <p:grpSpPr>
+        <a:xfrm>
+          <a:off x="0" y="0"/>
+          <a:ext cx="0" cy="0"/>
+          <a:chOff x="0" y="0"/>
+          <a:chExt cx="0" cy="0"/>
+        </a:xfrm>
+      </p:grpSpPr>
+      <p:sp>
+        <p:nvSpPr>
+          <p:cNvPr id="2" name="Title 1">
+            <a:extLst>
+              <a:ext uri="{FF2B5EF4-FFF2-40B4-BE49-F238E27FC236}">
+                <a16:creationId xmlns:a16="http://schemas.microsoft.com/office/drawing/2014/main" id="{726E0E2E-2CC0-99DC-F7D7-9C6005470BB7}"/>
+              </a:ext>
+            </a:extLst>
+          </p:cNvPr>
+          <p:cNvSpPr>
+            <a:spLocks noGrp="1"/>
+          </p:cNvSpPr>
+          <p:nvPr>
+            <p:ph type="title"/>
+          </p:nvPr>
+        </p:nvSpPr>
+        <p:spPr/>
+        <p:txBody>
+          <a:bodyPr/>
+          <a:lstStyle/>
+          <a:p>
+            <a:endParaRPr lang="en-US"/>
+          </a:p>
+        </p:txBody>
+      </p:sp>
+      <p:sp>
+        <p:nvSpPr>
+          <p:cNvPr id="3" name="Content Placeholder 2">
+            <a:extLst>
+              <a:ext uri="{FF2B5EF4-FFF2-40B4-BE49-F238E27FC236}">
+                <a16:creationId xmlns:a16="http://schemas.microsoft.com/office/drawing/2014/main" id="{3E08811F-4581-0FC5-1DA4-BB209DF3EC3E}"/>
+              </a:ext>
+            </a:extLst>
+          </p:cNvPr>
+          <p:cNvSpPr>
+            <a:spLocks noGrp="1"/>
+          </p:cNvSpPr>
+          <p:nvPr>
+            <p:ph idx="1"/>
+          </p:nvPr>
+        </p:nvSpPr>
+        <p:spPr/>
+        <p:txBody>
+          <a:bodyPr/>
+          <a:lstStyle/>
+          <a:p>
+            <a:endParaRPr lang="en-US"/>
+          </a:p>
+        </p:txBody>
+      </p:sp>
+    </p:spTree>
+    <p:extLst>
+      <p:ext uri="{BB962C8B-B14F-4D97-AF65-F5344CB8AC3E}">
+        <p14:creationId xmlns:p14="http://schemas.microsoft.com/office/powerpoint/2010/main" val="1539333578"/>
       </p:ext>
     </p:extLst>
   </p:cSld>

</xml_diff>